<commit_message>
feat: rewrite presentation with JTP template format and embedded images
- Download 10 food/sustainability images from Unsplash
- Rewrite create_presentation.py with full JTP template format
- Every slide has dark background with embedded image and overlay
- Section labels in CAPS at top-left on each slide
- Copyright footer on every slide
- Title slide includes JTP branding and author (Kaustubh Londhe)
- Slides 3-5 maintain problem+solution pair layout
- Slide 7 uses user-benefit language (no tech jargon)
- 10 pictures embedded across 10 slides
</commit_message>
<xml_diff>
--- a/SmartFoodManagement.pptx
+++ b/SmartFoodManagement.pptx
@@ -3097,12 +3097,20 @@
         <p:nvPr/>
       </p:nvGrpSpPr>
       <p:grpSpPr/>
-      <p:sp>
-        <p:nvSpPr>
-          <p:cNvPr id="2" name="Rectangle 1"/>
-          <p:cNvSpPr/>
-          <p:nvPr/>
-        </p:nvSpPr>
+      <p:pic>
+        <p:nvPicPr>
+          <p:cNvPr id="2" name="Picture 1" descr="01_title.jpg"/>
+          <p:cNvPicPr>
+            <a:picLocks noChangeAspect="1"/>
+          </p:cNvPicPr>
+          <p:nvPr/>
+        </p:nvPicPr>
+        <p:blipFill>
+          <a:blip r:embed="rId2"/>
+          <a:stretch>
+            <a:fillRect/>
+          </a:stretch>
+        </p:blipFill>
         <p:spPr>
           <a:xfrm>
             <a:off x="0" y="0"/>
@@ -3111,8 +3119,26 @@
           <a:prstGeom prst="rect">
             <a:avLst/>
           </a:prstGeom>
+        </p:spPr>
+      </p:pic>
+      <p:sp>
+        <p:nvSpPr>
+          <p:cNvPr id="3" name="Rectangle 2"/>
+          <p:cNvSpPr/>
+          <p:nvPr/>
+        </p:nvSpPr>
+        <p:spPr>
+          <a:xfrm>
+            <a:off x="0" y="0"/>
+            <a:ext cx="12191695" cy="6858000"/>
+          </a:xfrm>
+          <a:prstGeom prst="rect">
+            <a:avLst/>
+          </a:prstGeom>
           <a:solidFill>
-            <a:srgbClr val="1B2838"/>
+            <a:srgbClr val="1B2838">
+              <a:alpha val="75000"/>
+            </a:srgbClr>
           </a:solidFill>
           <a:ln>
             <a:noFill/>
@@ -3142,14 +3168,82 @@
       </p:sp>
       <p:sp>
         <p:nvSpPr>
-          <p:cNvPr id="3" name="Rectangle 2"/>
+          <p:cNvPr id="4" name="TextBox 3"/>
+          <p:cNvSpPr txBox="1"/>
+          <p:nvPr/>
+        </p:nvSpPr>
+        <p:spPr>
+          <a:xfrm>
+            <a:off x="457200" y="274320"/>
+            <a:ext cx="3657600" cy="365760"/>
+          </a:xfrm>
+          <a:prstGeom prst="rect">
+            <a:avLst/>
+          </a:prstGeom>
+          <a:noFill/>
+        </p:spPr>
+        <p:txBody>
+          <a:bodyPr wrap="square">
+            <a:spAutoFit/>
+          </a:bodyPr>
+          <a:lstStyle/>
+          <a:p>
+            <a:pPr algn="l"/>
+            <a:r>
+              <a:rPr sz="1400" b="1">
+                <a:solidFill>
+                  <a:srgbClr val="FFFFFF"/>
+                </a:solidFill>
+              </a:rPr>
+              <a:t>JTP Co., Ltd.</a:t>
+            </a:r>
+          </a:p>
+        </p:txBody>
+      </p:sp>
+      <p:sp>
+        <p:nvSpPr>
+          <p:cNvPr id="5" name="TextBox 4"/>
+          <p:cNvSpPr txBox="1"/>
+          <p:nvPr/>
+        </p:nvSpPr>
+        <p:spPr>
+          <a:xfrm>
+            <a:off x="457200" y="640080"/>
+            <a:ext cx="3657600" cy="365760"/>
+          </a:xfrm>
+          <a:prstGeom prst="rect">
+            <a:avLst/>
+          </a:prstGeom>
+          <a:noFill/>
+        </p:spPr>
+        <p:txBody>
+          <a:bodyPr wrap="square">
+            <a:spAutoFit/>
+          </a:bodyPr>
+          <a:lstStyle/>
+          <a:p>
+            <a:pPr algn="l"/>
+            <a:r>
+              <a:rPr sz="1200" b="0">
+                <a:solidFill>
+                  <a:srgbClr val="ECF0F1"/>
+                </a:solidFill>
+              </a:rPr>
+              <a:t>Kaustubh Londhe</a:t>
+            </a:r>
+          </a:p>
+        </p:txBody>
+      </p:sp>
+      <p:sp>
+        <p:nvSpPr>
+          <p:cNvPr id="6" name="Rectangle 5"/>
           <p:cNvSpPr/>
           <p:nvPr/>
         </p:nvSpPr>
         <p:spPr>
           <a:xfrm>
-            <a:off x="0" y="0"/>
-            <a:ext cx="365760" cy="6858000"/>
+            <a:off x="457200" y="2194560"/>
+            <a:ext cx="1828800" cy="73152"/>
           </a:xfrm>
           <a:prstGeom prst="rect">
             <a:avLst/>
@@ -3185,14 +3279,14 @@
       </p:sp>
       <p:sp>
         <p:nvSpPr>
-          <p:cNvPr id="4" name="TextBox 3"/>
+          <p:cNvPr id="7" name="TextBox 6"/>
           <p:cNvSpPr txBox="1"/>
           <p:nvPr/>
         </p:nvSpPr>
         <p:spPr>
           <a:xfrm>
-            <a:off x="8686800" y="914400"/>
-            <a:ext cx="2743200" cy="1828800"/>
+            <a:off x="457200" y="2377440"/>
+            <a:ext cx="7315200" cy="1097280"/>
           </a:xfrm>
           <a:prstGeom prst="rect">
             <a:avLst/>
@@ -3205,28 +3299,28 @@
           </a:bodyPr>
           <a:lstStyle/>
           <a:p>
-            <a:pPr algn="ctr"/>
-            <a:r>
-              <a:rPr sz="7200" b="0">
+            <a:pPr algn="l"/>
+            <a:r>
+              <a:rPr sz="4800" b="1">
                 <a:solidFill>
                   <a:srgbClr val="FFFFFF"/>
                 </a:solidFill>
               </a:rPr>
-              <a:t>🍽️</a:t>
-            </a:r>
-          </a:p>
-        </p:txBody>
-      </p:sp>
-      <p:sp>
-        <p:nvSpPr>
-          <p:cNvPr id="5" name="TextBox 4"/>
+              <a:t>Smart Food Management</a:t>
+            </a:r>
+          </a:p>
+        </p:txBody>
+      </p:sp>
+      <p:sp>
+        <p:nvSpPr>
+          <p:cNvPr id="8" name="TextBox 7"/>
           <p:cNvSpPr txBox="1"/>
           <p:nvPr/>
         </p:nvSpPr>
         <p:spPr>
           <a:xfrm>
-            <a:off x="1371600" y="1828800"/>
-            <a:ext cx="7315200" cy="1097280"/>
+            <a:off x="457200" y="3474720"/>
+            <a:ext cx="7315200" cy="731520"/>
           </a:xfrm>
           <a:prstGeom prst="rect">
             <a:avLst/>
@@ -3241,26 +3335,26 @@
           <a:p>
             <a:pPr algn="l"/>
             <a:r>
-              <a:rPr sz="4400" b="1">
-                <a:solidFill>
-                  <a:srgbClr val="FFFFFF"/>
+              <a:rPr sz="2400" b="0">
+                <a:solidFill>
+                  <a:srgbClr val="ECF0F1"/>
                 </a:solidFill>
               </a:rPr>
-              <a:t>Smart Food Management</a:t>
-            </a:r>
-          </a:p>
-        </p:txBody>
-      </p:sp>
-      <p:sp>
-        <p:nvSpPr>
-          <p:cNvPr id="6" name="TextBox 5"/>
+              <a:t>Intelligent Platform for Zero Food Waste</a:t>
+            </a:r>
+          </a:p>
+        </p:txBody>
+      </p:sp>
+      <p:sp>
+        <p:nvSpPr>
+          <p:cNvPr id="9" name="TextBox 8"/>
           <p:cNvSpPr txBox="1"/>
           <p:nvPr/>
         </p:nvSpPr>
         <p:spPr>
           <a:xfrm>
-            <a:off x="1371600" y="2926080"/>
-            <a:ext cx="7315200" cy="731520"/>
+            <a:off x="457200" y="4572000"/>
+            <a:ext cx="8229600" cy="731520"/>
           </a:xfrm>
           <a:prstGeom prst="rect">
             <a:avLst/>
@@ -3275,40 +3369,6 @@
           <a:p>
             <a:pPr algn="l"/>
             <a:r>
-              <a:rPr sz="2400" b="0">
-                <a:solidFill>
-                  <a:srgbClr val="ECF0F1"/>
-                </a:solidFill>
-              </a:rPr>
-              <a:t>Intelligent Platform for Zero Food Waste</a:t>
-            </a:r>
-          </a:p>
-        </p:txBody>
-      </p:sp>
-      <p:sp>
-        <p:nvSpPr>
-          <p:cNvPr id="7" name="TextBox 6"/>
-          <p:cNvSpPr txBox="1"/>
-          <p:nvPr/>
-        </p:nvSpPr>
-        <p:spPr>
-          <a:xfrm>
-            <a:off x="1371600" y="4114800"/>
-            <a:ext cx="8229600" cy="731520"/>
-          </a:xfrm>
-          <a:prstGeom prst="rect">
-            <a:avLst/>
-          </a:prstGeom>
-          <a:noFill/>
-        </p:spPr>
-        <p:txBody>
-          <a:bodyPr wrap="square">
-            <a:spAutoFit/>
-          </a:bodyPr>
-          <a:lstStyle/>
-          <a:p>
-            <a:pPr algn="l"/>
-            <a:r>
               <a:rPr sz="2800" b="1">
                 <a:solidFill>
                   <a:srgbClr val="F39C12"/>
@@ -3321,7 +3381,7 @@
       </p:sp>
       <p:sp>
         <p:nvSpPr>
-          <p:cNvPr id="8" name="TextBox 7"/>
+          <p:cNvPr id="10" name="TextBox 9"/>
           <p:cNvSpPr txBox="1"/>
           <p:nvPr/>
         </p:nvSpPr>
@@ -3371,12 +3431,20 @@
         <p:nvPr/>
       </p:nvGrpSpPr>
       <p:grpSpPr/>
-      <p:sp>
-        <p:nvSpPr>
-          <p:cNvPr id="2" name="Rectangle 1"/>
-          <p:cNvSpPr/>
-          <p:nvPr/>
-        </p:nvSpPr>
+      <p:pic>
+        <p:nvPicPr>
+          <p:cNvPr id="2" name="Picture 1" descr="09_fresh.jpg"/>
+          <p:cNvPicPr>
+            <a:picLocks noChangeAspect="1"/>
+          </p:cNvPicPr>
+          <p:nvPr/>
+        </p:nvPicPr>
+        <p:blipFill>
+          <a:blip r:embed="rId2"/>
+          <a:stretch>
+            <a:fillRect/>
+          </a:stretch>
+        </p:blipFill>
         <p:spPr>
           <a:xfrm>
             <a:off x="0" y="0"/>
@@ -3385,8 +3453,26 @@
           <a:prstGeom prst="rect">
             <a:avLst/>
           </a:prstGeom>
+        </p:spPr>
+      </p:pic>
+      <p:sp>
+        <p:nvSpPr>
+          <p:cNvPr id="3" name="Rectangle 2"/>
+          <p:cNvSpPr/>
+          <p:nvPr/>
+        </p:nvSpPr>
+        <p:spPr>
+          <a:xfrm>
+            <a:off x="0" y="0"/>
+            <a:ext cx="12191695" cy="6858000"/>
+          </a:xfrm>
+          <a:prstGeom prst="rect">
+            <a:avLst/>
+          </a:prstGeom>
           <a:solidFill>
-            <a:srgbClr val="1B2838"/>
+            <a:srgbClr val="1B2838">
+              <a:alpha val="60000"/>
+            </a:srgbClr>
           </a:solidFill>
           <a:ln>
             <a:noFill/>
@@ -3416,186 +3502,14 @@
       </p:sp>
       <p:sp>
         <p:nvSpPr>
-          <p:cNvPr id="3" name="Rectangle 2"/>
-          <p:cNvSpPr/>
-          <p:nvPr/>
-        </p:nvSpPr>
-        <p:spPr>
-          <a:xfrm>
-            <a:off x="10515600" y="0"/>
-            <a:ext cx="1676095" cy="365760"/>
-          </a:xfrm>
-          <a:prstGeom prst="rect">
-            <a:avLst/>
-          </a:prstGeom>
-          <a:solidFill>
-            <a:srgbClr val="2ECC71"/>
-          </a:solidFill>
-          <a:ln>
-            <a:noFill/>
-          </a:ln>
-        </p:spPr>
-        <p:style>
-          <a:lnRef idx="1">
-            <a:schemeClr val="accent1"/>
-          </a:lnRef>
-          <a:fillRef idx="3">
-            <a:schemeClr val="accent1"/>
-          </a:fillRef>
-          <a:effectRef idx="2">
-            <a:schemeClr val="accent1"/>
-          </a:effectRef>
-          <a:fontRef idx="minor">
-            <a:schemeClr val="lt1"/>
-          </a:fontRef>
-        </p:style>
-        <p:txBody>
-          <a:bodyPr rtlCol="0" anchor="ctr"/>
-          <a:lstStyle/>
-          <a:p>
-            <a:pPr algn="ctr"/>
-          </a:p>
-        </p:txBody>
-      </p:sp>
-      <p:sp>
-        <p:nvSpPr>
-          <p:cNvPr id="4" name="Rectangle 3"/>
-          <p:cNvSpPr/>
-          <p:nvPr/>
-        </p:nvSpPr>
-        <p:spPr>
-          <a:xfrm>
-            <a:off x="0" y="6492240"/>
-            <a:ext cx="1828800" cy="365760"/>
-          </a:xfrm>
-          <a:prstGeom prst="rect">
-            <a:avLst/>
-          </a:prstGeom>
-          <a:solidFill>
-            <a:srgbClr val="F39C12"/>
-          </a:solidFill>
-          <a:ln>
-            <a:noFill/>
-          </a:ln>
-        </p:spPr>
-        <p:style>
-          <a:lnRef idx="1">
-            <a:schemeClr val="accent1"/>
-          </a:lnRef>
-          <a:fillRef idx="3">
-            <a:schemeClr val="accent1"/>
-          </a:fillRef>
-          <a:effectRef idx="2">
-            <a:schemeClr val="accent1"/>
-          </a:effectRef>
-          <a:fontRef idx="minor">
-            <a:schemeClr val="lt1"/>
-          </a:fontRef>
-        </p:style>
-        <p:txBody>
-          <a:bodyPr rtlCol="0" anchor="ctr"/>
-          <a:lstStyle/>
-          <a:p>
-            <a:pPr algn="ctr"/>
-          </a:p>
-        </p:txBody>
-      </p:sp>
-      <p:sp>
-        <p:nvSpPr>
-          <p:cNvPr id="5" name="Oval 4"/>
-          <p:cNvSpPr/>
-          <p:nvPr/>
-        </p:nvSpPr>
-        <p:spPr>
-          <a:xfrm>
-            <a:off x="457200" y="457200"/>
-            <a:ext cx="548640" cy="548640"/>
-          </a:xfrm>
-          <a:prstGeom prst="ellipse">
-            <a:avLst/>
-          </a:prstGeom>
-          <a:solidFill>
-            <a:srgbClr val="2ECC71"/>
-          </a:solidFill>
-          <a:ln>
-            <a:noFill/>
-          </a:ln>
-        </p:spPr>
-        <p:style>
-          <a:lnRef idx="1">
-            <a:schemeClr val="accent1"/>
-          </a:lnRef>
-          <a:fillRef idx="3">
-            <a:schemeClr val="accent1"/>
-          </a:fillRef>
-          <a:effectRef idx="2">
-            <a:schemeClr val="accent1"/>
-          </a:effectRef>
-          <a:fontRef idx="minor">
-            <a:schemeClr val="lt1"/>
-          </a:fontRef>
-        </p:style>
-        <p:txBody>
-          <a:bodyPr rtlCol="0" anchor="ctr"/>
-          <a:lstStyle/>
-          <a:p>
-            <a:pPr algn="ctr"/>
-          </a:p>
-        </p:txBody>
-      </p:sp>
-      <p:sp>
-        <p:nvSpPr>
-          <p:cNvPr id="6" name="Oval 5"/>
-          <p:cNvSpPr/>
-          <p:nvPr/>
-        </p:nvSpPr>
-        <p:spPr>
-          <a:xfrm>
-            <a:off x="10972800" y="5486400"/>
-            <a:ext cx="457200" cy="457200"/>
-          </a:xfrm>
-          <a:prstGeom prst="ellipse">
-            <a:avLst/>
-          </a:prstGeom>
-          <a:solidFill>
-            <a:srgbClr val="F39C12"/>
-          </a:solidFill>
-          <a:ln>
-            <a:noFill/>
-          </a:ln>
-        </p:spPr>
-        <p:style>
-          <a:lnRef idx="1">
-            <a:schemeClr val="accent1"/>
-          </a:lnRef>
-          <a:fillRef idx="3">
-            <a:schemeClr val="accent1"/>
-          </a:fillRef>
-          <a:effectRef idx="2">
-            <a:schemeClr val="accent1"/>
-          </a:effectRef>
-          <a:fontRef idx="minor">
-            <a:schemeClr val="lt1"/>
-          </a:fontRef>
-        </p:style>
-        <p:txBody>
-          <a:bodyPr rtlCol="0" anchor="ctr"/>
-          <a:lstStyle/>
-          <a:p>
-            <a:pPr algn="ctr"/>
-          </a:p>
-        </p:txBody>
-      </p:sp>
-      <p:sp>
-        <p:nvSpPr>
-          <p:cNvPr id="7" name="TextBox 6"/>
+          <p:cNvPr id="4" name="TextBox 3"/>
           <p:cNvSpPr txBox="1"/>
           <p:nvPr/>
         </p:nvSpPr>
         <p:spPr>
           <a:xfrm>
-            <a:off x="5029200" y="914400"/>
-            <a:ext cx="2286000" cy="1371600"/>
+            <a:off x="1371600" y="2011680"/>
+            <a:ext cx="9448495" cy="1097280"/>
           </a:xfrm>
           <a:prstGeom prst="rect">
             <a:avLst/>
@@ -3610,26 +3524,26 @@
           <a:p>
             <a:pPr algn="ctr"/>
             <a:r>
-              <a:rPr sz="7200" b="0">
-                <a:solidFill>
-                  <a:srgbClr val="2ECC71"/>
+              <a:rPr sz="4800" b="1">
+                <a:solidFill>
+                  <a:srgbClr val="FFFFFF"/>
                 </a:solidFill>
               </a:rPr>
-              <a:t>🌱</a:t>
-            </a:r>
-          </a:p>
-        </p:txBody>
-      </p:sp>
-      <p:sp>
-        <p:nvSpPr>
-          <p:cNvPr id="8" name="TextBox 7"/>
+              <a:t>Smart Food Management</a:t>
+            </a:r>
+          </a:p>
+        </p:txBody>
+      </p:sp>
+      <p:sp>
+        <p:nvSpPr>
+          <p:cNvPr id="5" name="TextBox 4"/>
           <p:cNvSpPr txBox="1"/>
           <p:nvPr/>
         </p:nvSpPr>
         <p:spPr>
           <a:xfrm>
-            <a:off x="1371600" y="2560320"/>
-            <a:ext cx="9448495" cy="1097280"/>
+            <a:off x="1371600" y="3200400"/>
+            <a:ext cx="9448495" cy="731520"/>
           </a:xfrm>
           <a:prstGeom prst="rect">
             <a:avLst/>
@@ -3644,26 +3558,26 @@
           <a:p>
             <a:pPr algn="ctr"/>
             <a:r>
-              <a:rPr sz="4400" b="1">
-                <a:solidFill>
-                  <a:srgbClr val="FFFFFF"/>
+              <a:rPr sz="2800" b="1">
+                <a:solidFill>
+                  <a:srgbClr val="2ECC71"/>
                 </a:solidFill>
               </a:rPr>
-              <a:t>Smart Food Management</a:t>
-            </a:r>
-          </a:p>
-        </p:txBody>
-      </p:sp>
-      <p:sp>
-        <p:nvSpPr>
-          <p:cNvPr id="9" name="TextBox 8"/>
+              <a:t>Every Meal Matters. Zero Waste. Full Plates.</a:t>
+            </a:r>
+          </a:p>
+        </p:txBody>
+      </p:sp>
+      <p:sp>
+        <p:nvSpPr>
+          <p:cNvPr id="6" name="TextBox 5"/>
           <p:cNvSpPr txBox="1"/>
           <p:nvPr/>
         </p:nvSpPr>
         <p:spPr>
           <a:xfrm>
-            <a:off x="1371600" y="3657600"/>
-            <a:ext cx="9448495" cy="731520"/>
+            <a:off x="1371600" y="4572000"/>
+            <a:ext cx="9448495" cy="548640"/>
           </a:xfrm>
           <a:prstGeom prst="rect">
             <a:avLst/>
@@ -3678,41 +3592,7 @@
           <a:p>
             <a:pPr algn="ctr"/>
             <a:r>
-              <a:rPr sz="2800" b="1">
-                <a:solidFill>
-                  <a:srgbClr val="2ECC71"/>
-                </a:solidFill>
-              </a:rPr>
-              <a:t>Every Meal Matters. Zero Waste. Full Plates.</a:t>
-            </a:r>
-          </a:p>
-        </p:txBody>
-      </p:sp>
-      <p:sp>
-        <p:nvSpPr>
-          <p:cNvPr id="10" name="TextBox 9"/>
-          <p:cNvSpPr txBox="1"/>
-          <p:nvPr/>
-        </p:nvSpPr>
-        <p:spPr>
-          <a:xfrm>
-            <a:off x="1371600" y="4754880"/>
-            <a:ext cx="9448495" cy="548640"/>
-          </a:xfrm>
-          <a:prstGeom prst="rect">
-            <a:avLst/>
-          </a:prstGeom>
-          <a:noFill/>
-        </p:spPr>
-        <p:txBody>
-          <a:bodyPr wrap="square">
-            <a:spAutoFit/>
-          </a:bodyPr>
-          <a:lstStyle/>
-          <a:p>
-            <a:pPr algn="ctr"/>
-            <a:r>
-              <a:rPr sz="2000" b="0">
+              <a:rPr sz="2400" b="1">
                 <a:solidFill>
                   <a:srgbClr val="FFFFFF"/>
                 </a:solidFill>
@@ -3724,7 +3604,7 @@
       </p:sp>
       <p:sp>
         <p:nvSpPr>
-          <p:cNvPr id="11" name="TextBox 10"/>
+          <p:cNvPr id="7" name="TextBox 6"/>
           <p:cNvSpPr txBox="1"/>
           <p:nvPr/>
         </p:nvSpPr>
@@ -3774,12 +3654,20 @@
         <p:nvPr/>
       </p:nvGrpSpPr>
       <p:grpSpPr/>
-      <p:sp>
-        <p:nvSpPr>
-          <p:cNvPr id="2" name="Rectangle 1"/>
-          <p:cNvSpPr/>
-          <p:nvPr/>
-        </p:nvSpPr>
+      <p:pic>
+        <p:nvPicPr>
+          <p:cNvPr id="2" name="Picture 1" descr="02_crisis.jpg"/>
+          <p:cNvPicPr>
+            <a:picLocks noChangeAspect="1"/>
+          </p:cNvPicPr>
+          <p:nvPr/>
+        </p:nvPicPr>
+        <p:blipFill>
+          <a:blip r:embed="rId2"/>
+          <a:stretch>
+            <a:fillRect/>
+          </a:stretch>
+        </p:blipFill>
         <p:spPr>
           <a:xfrm>
             <a:off x="0" y="0"/>
@@ -3788,8 +3676,26 @@
           <a:prstGeom prst="rect">
             <a:avLst/>
           </a:prstGeom>
+        </p:spPr>
+      </p:pic>
+      <p:sp>
+        <p:nvSpPr>
+          <p:cNvPr id="3" name="Rectangle 2"/>
+          <p:cNvSpPr/>
+          <p:nvPr/>
+        </p:nvSpPr>
+        <p:spPr>
+          <a:xfrm>
+            <a:off x="0" y="0"/>
+            <a:ext cx="12191695" cy="6858000"/>
+          </a:xfrm>
+          <a:prstGeom prst="rect">
+            <a:avLst/>
+          </a:prstGeom>
           <a:solidFill>
-            <a:srgbClr val="1B2838"/>
+            <a:srgbClr val="1B2838">
+              <a:alpha val="75000"/>
+            </a:srgbClr>
           </a:solidFill>
           <a:ln>
             <a:noFill/>
@@ -3819,14 +3725,14 @@
       </p:sp>
       <p:sp>
         <p:nvSpPr>
-          <p:cNvPr id="3" name="TextBox 2"/>
+          <p:cNvPr id="4" name="TextBox 3"/>
           <p:cNvSpPr txBox="1"/>
           <p:nvPr/>
         </p:nvSpPr>
         <p:spPr>
           <a:xfrm>
-            <a:off x="457200" y="457200"/>
-            <a:ext cx="10972800" cy="914400"/>
+            <a:off x="457200" y="274320"/>
+            <a:ext cx="3657600" cy="365760"/>
           </a:xfrm>
           <a:prstGeom prst="rect">
             <a:avLst/>
@@ -3839,6 +3745,40 @@
           </a:bodyPr>
           <a:lstStyle/>
           <a:p>
+            <a:pPr algn="l"/>
+            <a:r>
+              <a:rPr sz="1100" b="1">
+                <a:solidFill>
+                  <a:srgbClr val="F39C12"/>
+                </a:solidFill>
+              </a:rPr>
+              <a:t>THE CRISIS</a:t>
+            </a:r>
+          </a:p>
+        </p:txBody>
+      </p:sp>
+      <p:sp>
+        <p:nvSpPr>
+          <p:cNvPr id="5" name="TextBox 4"/>
+          <p:cNvSpPr txBox="1"/>
+          <p:nvPr/>
+        </p:nvSpPr>
+        <p:spPr>
+          <a:xfrm>
+            <a:off x="457200" y="731520"/>
+            <a:ext cx="10972800" cy="914400"/>
+          </a:xfrm>
+          <a:prstGeom prst="rect">
+            <a:avLst/>
+          </a:prstGeom>
+          <a:noFill/>
+        </p:spPr>
+        <p:txBody>
+          <a:bodyPr wrap="square">
+            <a:spAutoFit/>
+          </a:bodyPr>
+          <a:lstStyle/>
+          <a:p>
             <a:pPr algn="ctr"/>
             <a:r>
               <a:rPr sz="3600" b="1">
@@ -3846,14 +3786,14 @@
                   <a:srgbClr val="FFFFFF"/>
                 </a:solidFill>
               </a:rPr>
-              <a:t>A Global Food Waste Crisis</a:t>
-            </a:r>
-          </a:p>
-        </p:txBody>
-      </p:sp>
-      <p:sp>
-        <p:nvSpPr>
-          <p:cNvPr id="4" name="Rounded Rectangle 3"/>
+              <a:t>Every Day, Food Goes to Waste</a:t>
+            </a:r>
+          </a:p>
+        </p:txBody>
+      </p:sp>
+      <p:sp>
+        <p:nvSpPr>
+          <p:cNvPr id="6" name="Rounded Rectangle 5"/>
           <p:cNvSpPr/>
           <p:nvPr/>
         </p:nvSpPr>
@@ -3896,7 +3836,7 @@
       </p:sp>
       <p:sp>
         <p:nvSpPr>
-          <p:cNvPr id="5" name="Rectangle 4"/>
+          <p:cNvPr id="7" name="Rectangle 6"/>
           <p:cNvSpPr/>
           <p:nvPr/>
         </p:nvSpPr>
@@ -3939,14 +3879,14 @@
       </p:sp>
       <p:sp>
         <p:nvSpPr>
-          <p:cNvPr id="6" name="TextBox 5"/>
+          <p:cNvPr id="8" name="TextBox 7"/>
           <p:cNvSpPr txBox="1"/>
           <p:nvPr/>
         </p:nvSpPr>
         <p:spPr>
           <a:xfrm>
-            <a:off x="1371600" y="2377440"/>
-            <a:ext cx="2651760" cy="914400"/>
+            <a:off x="1371600" y="2560320"/>
+            <a:ext cx="2651760" cy="1097280"/>
           </a:xfrm>
           <a:prstGeom prst="rect">
             <a:avLst/>
@@ -3961,26 +3901,26 @@
           <a:p>
             <a:pPr algn="ctr"/>
             <a:r>
-              <a:rPr sz="4800" b="0">
-                <a:solidFill>
-                  <a:srgbClr val="FFFFFF"/>
+              <a:rPr sz="4000" b="1">
+                <a:solidFill>
+                  <a:srgbClr val="F39C12"/>
                 </a:solidFill>
               </a:rPr>
-              <a:t>🗑️</a:t>
-            </a:r>
-          </a:p>
-        </p:txBody>
-      </p:sp>
-      <p:sp>
-        <p:nvSpPr>
-          <p:cNvPr id="7" name="TextBox 6"/>
+              <a:t>1.3B</a:t>
+            </a:r>
+          </a:p>
+        </p:txBody>
+      </p:sp>
+      <p:sp>
+        <p:nvSpPr>
+          <p:cNvPr id="9" name="TextBox 8"/>
           <p:cNvSpPr txBox="1"/>
           <p:nvPr/>
         </p:nvSpPr>
         <p:spPr>
           <a:xfrm>
-            <a:off x="1371600" y="3383280"/>
-            <a:ext cx="2651760" cy="731520"/>
+            <a:off x="1371600" y="3474720"/>
+            <a:ext cx="2651760" cy="548640"/>
           </a:xfrm>
           <a:prstGeom prst="rect">
             <a:avLst/>
@@ -3995,19 +3935,19 @@
           <a:p>
             <a:pPr algn="ctr"/>
             <a:r>
-              <a:rPr sz="3200" b="1">
-                <a:solidFill>
-                  <a:srgbClr val="F39C12"/>
+              <a:rPr sz="2200" b="1">
+                <a:solidFill>
+                  <a:srgbClr val="FFFFFF"/>
                 </a:solidFill>
               </a:rPr>
-              <a:t>1.3B Tonnes</a:t>
-            </a:r>
-          </a:p>
-        </p:txBody>
-      </p:sp>
-      <p:sp>
-        <p:nvSpPr>
-          <p:cNvPr id="8" name="TextBox 7"/>
+              <a:t>Tonnes</a:t>
+            </a:r>
+          </a:p>
+        </p:txBody>
+      </p:sp>
+      <p:sp>
+        <p:nvSpPr>
+          <p:cNvPr id="10" name="TextBox 9"/>
           <p:cNvSpPr txBox="1"/>
           <p:nvPr/>
         </p:nvSpPr>
@@ -4041,7 +3981,7 @@
       </p:sp>
       <p:sp>
         <p:nvSpPr>
-          <p:cNvPr id="9" name="Rounded Rectangle 8"/>
+          <p:cNvPr id="11" name="Rounded Rectangle 10"/>
           <p:cNvSpPr/>
           <p:nvPr/>
         </p:nvSpPr>
@@ -4084,7 +4024,7 @@
       </p:sp>
       <p:sp>
         <p:nvSpPr>
-          <p:cNvPr id="10" name="Rectangle 9"/>
+          <p:cNvPr id="12" name="Rectangle 11"/>
           <p:cNvSpPr/>
           <p:nvPr/>
         </p:nvSpPr>
@@ -4127,14 +4067,14 @@
       </p:sp>
       <p:sp>
         <p:nvSpPr>
-          <p:cNvPr id="11" name="TextBox 10"/>
+          <p:cNvPr id="13" name="TextBox 12"/>
           <p:cNvSpPr txBox="1"/>
           <p:nvPr/>
         </p:nvSpPr>
         <p:spPr>
           <a:xfrm>
-            <a:off x="5029200" y="2377440"/>
-            <a:ext cx="2651760" cy="914400"/>
+            <a:off x="5029200" y="2560320"/>
+            <a:ext cx="2651760" cy="1097280"/>
           </a:xfrm>
           <a:prstGeom prst="rect">
             <a:avLst/>
@@ -4149,25 +4089,25 @@
           <a:p>
             <a:pPr algn="ctr"/>
             <a:r>
-              <a:rPr sz="4800" b="0">
-                <a:solidFill>
-                  <a:srgbClr val="FFFFFF"/>
+              <a:rPr sz="4000" b="1">
+                <a:solidFill>
+                  <a:srgbClr val="F39C12"/>
                 </a:solidFill>
               </a:rPr>
-              <a:t>💰</a:t>
-            </a:r>
-          </a:p>
-        </p:txBody>
-      </p:sp>
-      <p:sp>
-        <p:nvSpPr>
-          <p:cNvPr id="12" name="TextBox 11"/>
+              <a:t>$1 Trillion</a:t>
+            </a:r>
+          </a:p>
+        </p:txBody>
+      </p:sp>
+      <p:sp>
+        <p:nvSpPr>
+          <p:cNvPr id="14" name="TextBox 13"/>
           <p:cNvSpPr txBox="1"/>
           <p:nvPr/>
         </p:nvSpPr>
         <p:spPr>
           <a:xfrm>
-            <a:off x="5029200" y="3383280"/>
+            <a:off x="5029200" y="4206240"/>
             <a:ext cx="2651760" cy="731520"/>
           </a:xfrm>
           <a:prstGeom prst="rect">
@@ -4183,40 +4123,6 @@
           <a:p>
             <a:pPr algn="ctr"/>
             <a:r>
-              <a:rPr sz="3200" b="1">
-                <a:solidFill>
-                  <a:srgbClr val="F39C12"/>
-                </a:solidFill>
-              </a:rPr>
-              <a:t>$1 Trillion</a:t>
-            </a:r>
-          </a:p>
-        </p:txBody>
-      </p:sp>
-      <p:sp>
-        <p:nvSpPr>
-          <p:cNvPr id="13" name="TextBox 12"/>
-          <p:cNvSpPr txBox="1"/>
-          <p:nvPr/>
-        </p:nvSpPr>
-        <p:spPr>
-          <a:xfrm>
-            <a:off x="5029200" y="4206240"/>
-            <a:ext cx="2651760" cy="731520"/>
-          </a:xfrm>
-          <a:prstGeom prst="rect">
-            <a:avLst/>
-          </a:prstGeom>
-          <a:noFill/>
-        </p:spPr>
-        <p:txBody>
-          <a:bodyPr wrap="square">
-            <a:spAutoFit/>
-          </a:bodyPr>
-          <a:lstStyle/>
-          <a:p>
-            <a:pPr algn="ctr"/>
-            <a:r>
               <a:rPr sz="1800" b="0">
                 <a:solidFill>
                   <a:srgbClr val="ECF0F1"/>
@@ -4229,7 +4135,7 @@
       </p:sp>
       <p:sp>
         <p:nvSpPr>
-          <p:cNvPr id="14" name="Rounded Rectangle 13"/>
+          <p:cNvPr id="15" name="Rounded Rectangle 14"/>
           <p:cNvSpPr/>
           <p:nvPr/>
         </p:nvSpPr>
@@ -4272,7 +4178,7 @@
       </p:sp>
       <p:sp>
         <p:nvSpPr>
-          <p:cNvPr id="15" name="Rectangle 14"/>
+          <p:cNvPr id="16" name="Rectangle 15"/>
           <p:cNvSpPr/>
           <p:nvPr/>
         </p:nvSpPr>
@@ -4315,14 +4221,14 @@
       </p:sp>
       <p:sp>
         <p:nvSpPr>
-          <p:cNvPr id="16" name="TextBox 15"/>
+          <p:cNvPr id="17" name="TextBox 16"/>
           <p:cNvSpPr txBox="1"/>
           <p:nvPr/>
         </p:nvSpPr>
         <p:spPr>
           <a:xfrm>
-            <a:off x="8686800" y="2377440"/>
-            <a:ext cx="2651760" cy="914400"/>
+            <a:off x="8686800" y="2560320"/>
+            <a:ext cx="2651760" cy="1097280"/>
           </a:xfrm>
           <a:prstGeom prst="rect">
             <a:avLst/>
@@ -4337,41 +4243,7 @@
           <a:p>
             <a:pPr algn="ctr"/>
             <a:r>
-              <a:rPr sz="4800" b="0">
-                <a:solidFill>
-                  <a:srgbClr val="FFFFFF"/>
-                </a:solidFill>
-              </a:rPr>
-              <a:t>😢</a:t>
-            </a:r>
-          </a:p>
-        </p:txBody>
-      </p:sp>
-      <p:sp>
-        <p:nvSpPr>
-          <p:cNvPr id="17" name="TextBox 16"/>
-          <p:cNvSpPr txBox="1"/>
-          <p:nvPr/>
-        </p:nvSpPr>
-        <p:spPr>
-          <a:xfrm>
-            <a:off x="8686800" y="3383280"/>
-            <a:ext cx="2651760" cy="731520"/>
-          </a:xfrm>
-          <a:prstGeom prst="rect">
-            <a:avLst/>
-          </a:prstGeom>
-          <a:noFill/>
-        </p:spPr>
-        <p:txBody>
-          <a:bodyPr wrap="square">
-            <a:spAutoFit/>
-          </a:bodyPr>
-          <a:lstStyle/>
-          <a:p>
-            <a:pPr algn="ctr"/>
-            <a:r>
-              <a:rPr sz="3200" b="1">
+              <a:rPr sz="4000" b="1">
                 <a:solidFill>
                   <a:srgbClr val="E74C3C"/>
                 </a:solidFill>
@@ -4467,12 +4339,20 @@
         <p:nvPr/>
       </p:nvGrpSpPr>
       <p:grpSpPr/>
-      <p:sp>
-        <p:nvSpPr>
-          <p:cNvPr id="2" name="Rectangle 1"/>
-          <p:cNvSpPr/>
-          <p:nvPr/>
-        </p:nvSpPr>
+      <p:pic>
+        <p:nvPicPr>
+          <p:cNvPr id="2" name="Picture 1" descr="03_fridge.jpg"/>
+          <p:cNvPicPr>
+            <a:picLocks noChangeAspect="1"/>
+          </p:cNvPicPr>
+          <p:nvPr/>
+        </p:nvPicPr>
+        <p:blipFill>
+          <a:blip r:embed="rId2"/>
+          <a:stretch>
+            <a:fillRect/>
+          </a:stretch>
+        </p:blipFill>
         <p:spPr>
           <a:xfrm>
             <a:off x="0" y="0"/>
@@ -4481,8 +4361,26 @@
           <a:prstGeom prst="rect">
             <a:avLst/>
           </a:prstGeom>
+        </p:spPr>
+      </p:pic>
+      <p:sp>
+        <p:nvSpPr>
+          <p:cNvPr id="3" name="Rectangle 2"/>
+          <p:cNvSpPr/>
+          <p:nvPr/>
+        </p:nvSpPr>
+        <p:spPr>
+          <a:xfrm>
+            <a:off x="0" y="0"/>
+            <a:ext cx="12191695" cy="6858000"/>
+          </a:xfrm>
+          <a:prstGeom prst="rect">
+            <a:avLst/>
+          </a:prstGeom>
           <a:solidFill>
-            <a:srgbClr val="1B2838"/>
+            <a:srgbClr val="1B2838">
+              <a:alpha val="75000"/>
+            </a:srgbClr>
           </a:solidFill>
           <a:ln>
             <a:noFill/>
@@ -4512,14 +4410,14 @@
       </p:sp>
       <p:sp>
         <p:nvSpPr>
-          <p:cNvPr id="3" name="TextBox 2"/>
+          <p:cNvPr id="4" name="TextBox 3"/>
           <p:cNvSpPr txBox="1"/>
           <p:nvPr/>
         </p:nvSpPr>
         <p:spPr>
           <a:xfrm>
-            <a:off x="457200" y="365760"/>
-            <a:ext cx="10972800" cy="548640"/>
+            <a:off x="457200" y="274320"/>
+            <a:ext cx="3657600" cy="365760"/>
           </a:xfrm>
           <a:prstGeom prst="rect">
             <a:avLst/>
@@ -4532,21 +4430,21 @@
           </a:bodyPr>
           <a:lstStyle/>
           <a:p>
-            <a:pPr algn="ctr"/>
-            <a:r>
-              <a:rPr sz="1800" b="0">
-                <a:solidFill>
-                  <a:srgbClr val="ECF0F1"/>
+            <a:pPr algn="l"/>
+            <a:r>
+              <a:rPr sz="1100" b="1">
+                <a:solidFill>
+                  <a:srgbClr val="F39C12"/>
                 </a:solidFill>
               </a:rPr>
-              <a:t>The Challenge &amp; Our Answer</a:t>
-            </a:r>
-          </a:p>
-        </p:txBody>
-      </p:sp>
-      <p:sp>
-        <p:nvSpPr>
-          <p:cNvPr id="4" name="Rounded Rectangle 3"/>
+              <a:t>THE CHALLENGE &amp; SOLUTION</a:t>
+            </a:r>
+          </a:p>
+        </p:txBody>
+      </p:sp>
+      <p:sp>
+        <p:nvSpPr>
+          <p:cNvPr id="5" name="Rounded Rectangle 4"/>
           <p:cNvSpPr/>
           <p:nvPr/>
         </p:nvSpPr>
@@ -4589,7 +4487,7 @@
       </p:sp>
       <p:sp>
         <p:nvSpPr>
-          <p:cNvPr id="5" name="Rectangle 4"/>
+          <p:cNvPr id="6" name="Rectangle 5"/>
           <p:cNvSpPr/>
           <p:nvPr/>
         </p:nvSpPr>
@@ -4632,14 +4530,14 @@
       </p:sp>
       <p:sp>
         <p:nvSpPr>
-          <p:cNvPr id="6" name="TextBox 5"/>
+          <p:cNvPr id="7" name="TextBox 6"/>
           <p:cNvSpPr txBox="1"/>
           <p:nvPr/>
         </p:nvSpPr>
         <p:spPr>
           <a:xfrm>
-            <a:off x="1188720" y="1828800"/>
-            <a:ext cx="3840480" cy="1097280"/>
+            <a:off x="1188720" y="1737360"/>
+            <a:ext cx="3840480" cy="457200"/>
           </a:xfrm>
           <a:prstGeom prst="rect">
             <a:avLst/>
@@ -4654,25 +4552,25 @@
           <a:p>
             <a:pPr algn="ctr"/>
             <a:r>
-              <a:rPr sz="4800" b="0">
-                <a:solidFill>
-                  <a:srgbClr val="FFFFFF"/>
+              <a:rPr sz="1200" b="1">
+                <a:solidFill>
+                  <a:srgbClr val="E74C3C"/>
                 </a:solidFill>
               </a:rPr>
-              <a:t>🚫</a:t>
-            </a:r>
-          </a:p>
-        </p:txBody>
-      </p:sp>
-      <p:sp>
-        <p:nvSpPr>
-          <p:cNvPr id="7" name="TextBox 6"/>
+              <a:t>THE PROBLEM</a:t>
+            </a:r>
+          </a:p>
+        </p:txBody>
+      </p:sp>
+      <p:sp>
+        <p:nvSpPr>
+          <p:cNvPr id="8" name="TextBox 7"/>
           <p:cNvSpPr txBox="1"/>
           <p:nvPr/>
         </p:nvSpPr>
         <p:spPr>
           <a:xfrm>
-            <a:off x="1188720" y="3017520"/>
+            <a:off x="1188720" y="2468880"/>
             <a:ext cx="3840480" cy="640080"/>
           </a:xfrm>
           <a:prstGeom prst="rect">
@@ -4688,7 +4586,7 @@
           <a:p>
             <a:pPr algn="ctr"/>
             <a:r>
-              <a:rPr sz="2400" b="1">
+              <a:rPr sz="2600" b="1">
                 <a:solidFill>
                   <a:srgbClr val="FFFFFF"/>
                 </a:solidFill>
@@ -4700,13 +4598,13 @@
       </p:sp>
       <p:sp>
         <p:nvSpPr>
-          <p:cNvPr id="8" name="TextBox 7"/>
+          <p:cNvPr id="9" name="TextBox 8"/>
           <p:cNvSpPr txBox="1"/>
           <p:nvPr/>
         </p:nvSpPr>
         <p:spPr>
           <a:xfrm>
-            <a:off x="1188720" y="3840480"/>
+            <a:off x="1188720" y="3383280"/>
             <a:ext cx="3840480" cy="1371600"/>
           </a:xfrm>
           <a:prstGeom prst="rect">
@@ -4734,7 +4632,7 @@
       </p:sp>
       <p:sp>
         <p:nvSpPr>
-          <p:cNvPr id="9" name="TextBox 8"/>
+          <p:cNvPr id="10" name="TextBox 9"/>
           <p:cNvSpPr txBox="1"/>
           <p:nvPr/>
         </p:nvSpPr>
@@ -4768,7 +4666,7 @@
       </p:sp>
       <p:sp>
         <p:nvSpPr>
-          <p:cNvPr id="10" name="Rounded Rectangle 9"/>
+          <p:cNvPr id="11" name="Rounded Rectangle 10"/>
           <p:cNvSpPr/>
           <p:nvPr/>
         </p:nvSpPr>
@@ -4811,7 +4709,7 @@
       </p:sp>
       <p:sp>
         <p:nvSpPr>
-          <p:cNvPr id="11" name="Rectangle 10"/>
+          <p:cNvPr id="12" name="Rectangle 11"/>
           <p:cNvSpPr/>
           <p:nvPr/>
         </p:nvSpPr>
@@ -4854,14 +4752,14 @@
       </p:sp>
       <p:sp>
         <p:nvSpPr>
-          <p:cNvPr id="12" name="TextBox 11"/>
+          <p:cNvPr id="13" name="TextBox 12"/>
           <p:cNvSpPr txBox="1"/>
           <p:nvPr/>
         </p:nvSpPr>
         <p:spPr>
           <a:xfrm>
-            <a:off x="7040880" y="1828800"/>
-            <a:ext cx="3840480" cy="1097280"/>
+            <a:off x="7040880" y="1737360"/>
+            <a:ext cx="3840480" cy="457200"/>
           </a:xfrm>
           <a:prstGeom prst="rect">
             <a:avLst/>
@@ -4876,25 +4774,25 @@
           <a:p>
             <a:pPr algn="ctr"/>
             <a:r>
-              <a:rPr sz="4800" b="0">
-                <a:solidFill>
-                  <a:srgbClr val="FFFFFF"/>
+              <a:rPr sz="1200" b="1">
+                <a:solidFill>
+                  <a:srgbClr val="2ECC71"/>
                 </a:solidFill>
               </a:rPr>
-              <a:t>✅</a:t>
-            </a:r>
-          </a:p>
-        </p:txBody>
-      </p:sp>
-      <p:sp>
-        <p:nvSpPr>
-          <p:cNvPr id="13" name="TextBox 12"/>
+              <a:t>THE SOLUTION</a:t>
+            </a:r>
+          </a:p>
+        </p:txBody>
+      </p:sp>
+      <p:sp>
+        <p:nvSpPr>
+          <p:cNvPr id="14" name="TextBox 13"/>
           <p:cNvSpPr txBox="1"/>
           <p:nvPr/>
         </p:nvSpPr>
         <p:spPr>
           <a:xfrm>
-            <a:off x="7040880" y="3017520"/>
+            <a:off x="7040880" y="2468880"/>
             <a:ext cx="3840480" cy="640080"/>
           </a:xfrm>
           <a:prstGeom prst="rect">
@@ -4910,7 +4808,7 @@
           <a:p>
             <a:pPr algn="ctr"/>
             <a:r>
-              <a:rPr sz="2400" b="1">
+              <a:rPr sz="2600" b="1">
                 <a:solidFill>
                   <a:srgbClr val="2ECC71"/>
                 </a:solidFill>
@@ -4922,13 +4820,13 @@
       </p:sp>
       <p:sp>
         <p:nvSpPr>
-          <p:cNvPr id="14" name="TextBox 13"/>
+          <p:cNvPr id="15" name="TextBox 14"/>
           <p:cNvSpPr txBox="1"/>
           <p:nvPr/>
         </p:nvSpPr>
         <p:spPr>
           <a:xfrm>
-            <a:off x="7040880" y="3840480"/>
+            <a:off x="7040880" y="3383280"/>
             <a:ext cx="3840480" cy="1371600"/>
           </a:xfrm>
           <a:prstGeom prst="rect">
@@ -4956,7 +4854,7 @@
       </p:sp>
       <p:sp>
         <p:nvSpPr>
-          <p:cNvPr id="15" name="TextBox 14"/>
+          <p:cNvPr id="16" name="TextBox 15"/>
           <p:cNvSpPr txBox="1"/>
           <p:nvPr/>
         </p:nvSpPr>
@@ -5006,12 +4904,20 @@
         <p:nvPr/>
       </p:nvGrpSpPr>
       <p:grpSpPr/>
-      <p:sp>
-        <p:nvSpPr>
-          <p:cNvPr id="2" name="Rectangle 1"/>
-          <p:cNvSpPr/>
-          <p:nvPr/>
-        </p:nvSpPr>
+      <p:pic>
+        <p:nvPicPr>
+          <p:cNvPr id="2" name="Picture 1" descr="04_donation.jpg"/>
+          <p:cNvPicPr>
+            <a:picLocks noChangeAspect="1"/>
+          </p:cNvPicPr>
+          <p:nvPr/>
+        </p:nvPicPr>
+        <p:blipFill>
+          <a:blip r:embed="rId2"/>
+          <a:stretch>
+            <a:fillRect/>
+          </a:stretch>
+        </p:blipFill>
         <p:spPr>
           <a:xfrm>
             <a:off x="0" y="0"/>
@@ -5020,8 +4926,26 @@
           <a:prstGeom prst="rect">
             <a:avLst/>
           </a:prstGeom>
+        </p:spPr>
+      </p:pic>
+      <p:sp>
+        <p:nvSpPr>
+          <p:cNvPr id="3" name="Rectangle 2"/>
+          <p:cNvSpPr/>
+          <p:nvPr/>
+        </p:nvSpPr>
+        <p:spPr>
+          <a:xfrm>
+            <a:off x="0" y="0"/>
+            <a:ext cx="12191695" cy="6858000"/>
+          </a:xfrm>
+          <a:prstGeom prst="rect">
+            <a:avLst/>
+          </a:prstGeom>
           <a:solidFill>
-            <a:srgbClr val="1B2838"/>
+            <a:srgbClr val="1B2838">
+              <a:alpha val="75000"/>
+            </a:srgbClr>
           </a:solidFill>
           <a:ln>
             <a:noFill/>
@@ -5051,14 +4975,14 @@
       </p:sp>
       <p:sp>
         <p:nvSpPr>
-          <p:cNvPr id="3" name="TextBox 2"/>
+          <p:cNvPr id="4" name="TextBox 3"/>
           <p:cNvSpPr txBox="1"/>
           <p:nvPr/>
         </p:nvSpPr>
         <p:spPr>
           <a:xfrm>
-            <a:off x="457200" y="365760"/>
-            <a:ext cx="10972800" cy="548640"/>
+            <a:off x="457200" y="274320"/>
+            <a:ext cx="3657600" cy="365760"/>
           </a:xfrm>
           <a:prstGeom prst="rect">
             <a:avLst/>
@@ -5071,21 +4995,21 @@
           </a:bodyPr>
           <a:lstStyle/>
           <a:p>
-            <a:pPr algn="ctr"/>
-            <a:r>
-              <a:rPr sz="1800" b="0">
-                <a:solidFill>
-                  <a:srgbClr val="ECF0F1"/>
+            <a:pPr algn="l"/>
+            <a:r>
+              <a:rPr sz="1100" b="1">
+                <a:solidFill>
+                  <a:srgbClr val="F39C12"/>
                 </a:solidFill>
               </a:rPr>
-              <a:t>The Challenge &amp; Our Answer</a:t>
-            </a:r>
-          </a:p>
-        </p:txBody>
-      </p:sp>
-      <p:sp>
-        <p:nvSpPr>
-          <p:cNvPr id="4" name="Rounded Rectangle 3"/>
+              <a:t>THE CHALLENGE &amp; SOLUTION</a:t>
+            </a:r>
+          </a:p>
+        </p:txBody>
+      </p:sp>
+      <p:sp>
+        <p:nvSpPr>
+          <p:cNvPr id="5" name="Rounded Rectangle 4"/>
           <p:cNvSpPr/>
           <p:nvPr/>
         </p:nvSpPr>
@@ -5128,7 +5052,7 @@
       </p:sp>
       <p:sp>
         <p:nvSpPr>
-          <p:cNvPr id="5" name="Rectangle 4"/>
+          <p:cNvPr id="6" name="Rectangle 5"/>
           <p:cNvSpPr/>
           <p:nvPr/>
         </p:nvSpPr>
@@ -5171,14 +5095,14 @@
       </p:sp>
       <p:sp>
         <p:nvSpPr>
-          <p:cNvPr id="6" name="TextBox 5"/>
+          <p:cNvPr id="7" name="TextBox 6"/>
           <p:cNvSpPr txBox="1"/>
           <p:nvPr/>
         </p:nvSpPr>
         <p:spPr>
           <a:xfrm>
-            <a:off x="1188720" y="1828800"/>
-            <a:ext cx="3840480" cy="1097280"/>
+            <a:off x="1188720" y="1737360"/>
+            <a:ext cx="3840480" cy="457200"/>
           </a:xfrm>
           <a:prstGeom prst="rect">
             <a:avLst/>
@@ -5193,25 +5117,25 @@
           <a:p>
             <a:pPr algn="ctr"/>
             <a:r>
-              <a:rPr sz="4800" b="0">
-                <a:solidFill>
-                  <a:srgbClr val="FFFFFF"/>
+              <a:rPr sz="1200" b="1">
+                <a:solidFill>
+                  <a:srgbClr val="E74C3C"/>
                 </a:solidFill>
               </a:rPr>
-              <a:t>🏪</a:t>
-            </a:r>
-          </a:p>
-        </p:txBody>
-      </p:sp>
-      <p:sp>
-        <p:nvSpPr>
-          <p:cNvPr id="7" name="TextBox 6"/>
+              <a:t>THE PROBLEM</a:t>
+            </a:r>
+          </a:p>
+        </p:txBody>
+      </p:sp>
+      <p:sp>
+        <p:nvSpPr>
+          <p:cNvPr id="8" name="TextBox 7"/>
           <p:cNvSpPr txBox="1"/>
           <p:nvPr/>
         </p:nvSpPr>
         <p:spPr>
           <a:xfrm>
-            <a:off x="1188720" y="3017520"/>
+            <a:off x="1188720" y="2468880"/>
             <a:ext cx="3840480" cy="640080"/>
           </a:xfrm>
           <a:prstGeom prst="rect">
@@ -5227,7 +5151,7 @@
           <a:p>
             <a:pPr algn="ctr"/>
             <a:r>
-              <a:rPr sz="2400" b="1">
+              <a:rPr sz="2600" b="1">
                 <a:solidFill>
                   <a:srgbClr val="FFFFFF"/>
                 </a:solidFill>
@@ -5239,13 +5163,13 @@
       </p:sp>
       <p:sp>
         <p:nvSpPr>
-          <p:cNvPr id="8" name="TextBox 7"/>
+          <p:cNvPr id="9" name="TextBox 8"/>
           <p:cNvSpPr txBox="1"/>
           <p:nvPr/>
         </p:nvSpPr>
         <p:spPr>
           <a:xfrm>
-            <a:off x="1188720" y="3840480"/>
+            <a:off x="1188720" y="3383280"/>
             <a:ext cx="3840480" cy="1371600"/>
           </a:xfrm>
           <a:prstGeom prst="rect">
@@ -5273,7 +5197,7 @@
       </p:sp>
       <p:sp>
         <p:nvSpPr>
-          <p:cNvPr id="9" name="TextBox 8"/>
+          <p:cNvPr id="10" name="TextBox 9"/>
           <p:cNvSpPr txBox="1"/>
           <p:nvPr/>
         </p:nvSpPr>
@@ -5307,7 +5231,7 @@
       </p:sp>
       <p:sp>
         <p:nvSpPr>
-          <p:cNvPr id="10" name="Rounded Rectangle 9"/>
+          <p:cNvPr id="11" name="Rounded Rectangle 10"/>
           <p:cNvSpPr/>
           <p:nvPr/>
         </p:nvSpPr>
@@ -5350,7 +5274,7 @@
       </p:sp>
       <p:sp>
         <p:nvSpPr>
-          <p:cNvPr id="11" name="Rectangle 10"/>
+          <p:cNvPr id="12" name="Rectangle 11"/>
           <p:cNvSpPr/>
           <p:nvPr/>
         </p:nvSpPr>
@@ -5393,14 +5317,14 @@
       </p:sp>
       <p:sp>
         <p:nvSpPr>
-          <p:cNvPr id="12" name="TextBox 11"/>
+          <p:cNvPr id="13" name="TextBox 12"/>
           <p:cNvSpPr txBox="1"/>
           <p:nvPr/>
         </p:nvSpPr>
         <p:spPr>
           <a:xfrm>
-            <a:off x="7040880" y="1828800"/>
-            <a:ext cx="3840480" cy="1097280"/>
+            <a:off x="7040880" y="1737360"/>
+            <a:ext cx="3840480" cy="457200"/>
           </a:xfrm>
           <a:prstGeom prst="rect">
             <a:avLst/>
@@ -5415,25 +5339,25 @@
           <a:p>
             <a:pPr algn="ctr"/>
             <a:r>
-              <a:rPr sz="4800" b="0">
-                <a:solidFill>
-                  <a:srgbClr val="FFFFFF"/>
+              <a:rPr sz="1200" b="1">
+                <a:solidFill>
+                  <a:srgbClr val="2ECC71"/>
                 </a:solidFill>
               </a:rPr>
-              <a:t>🤝</a:t>
-            </a:r>
-          </a:p>
-        </p:txBody>
-      </p:sp>
-      <p:sp>
-        <p:nvSpPr>
-          <p:cNvPr id="13" name="TextBox 12"/>
+              <a:t>THE SOLUTION</a:t>
+            </a:r>
+          </a:p>
+        </p:txBody>
+      </p:sp>
+      <p:sp>
+        <p:nvSpPr>
+          <p:cNvPr id="14" name="TextBox 13"/>
           <p:cNvSpPr txBox="1"/>
           <p:nvPr/>
         </p:nvSpPr>
         <p:spPr>
           <a:xfrm>
-            <a:off x="7040880" y="3017520"/>
+            <a:off x="7040880" y="2468880"/>
             <a:ext cx="3840480" cy="640080"/>
           </a:xfrm>
           <a:prstGeom prst="rect">
@@ -5449,7 +5373,7 @@
           <a:p>
             <a:pPr algn="ctr"/>
             <a:r>
-              <a:rPr sz="2400" b="1">
+              <a:rPr sz="2600" b="1">
                 <a:solidFill>
                   <a:srgbClr val="2ECC71"/>
                 </a:solidFill>
@@ -5461,13 +5385,13 @@
       </p:sp>
       <p:sp>
         <p:nvSpPr>
-          <p:cNvPr id="14" name="TextBox 13"/>
+          <p:cNvPr id="15" name="TextBox 14"/>
           <p:cNvSpPr txBox="1"/>
           <p:nvPr/>
         </p:nvSpPr>
         <p:spPr>
           <a:xfrm>
-            <a:off x="7040880" y="3840480"/>
+            <a:off x="7040880" y="3383280"/>
             <a:ext cx="3840480" cy="1371600"/>
           </a:xfrm>
           <a:prstGeom prst="rect">
@@ -5495,7 +5419,7 @@
       </p:sp>
       <p:sp>
         <p:nvSpPr>
-          <p:cNvPr id="15" name="TextBox 14"/>
+          <p:cNvPr id="16" name="TextBox 15"/>
           <p:cNvSpPr txBox="1"/>
           <p:nvPr/>
         </p:nvSpPr>
@@ -5545,12 +5469,20 @@
         <p:nvPr/>
       </p:nvGrpSpPr>
       <p:grpSpPr/>
-      <p:sp>
-        <p:nvSpPr>
-          <p:cNvPr id="2" name="Rectangle 1"/>
-          <p:cNvSpPr/>
-          <p:nvPr/>
-        </p:nvSpPr>
+      <p:pic>
+        <p:nvPicPr>
+          <p:cNvPr id="2" name="Picture 1" descr="05_cooking.jpg"/>
+          <p:cNvPicPr>
+            <a:picLocks noChangeAspect="1"/>
+          </p:cNvPicPr>
+          <p:nvPr/>
+        </p:nvPicPr>
+        <p:blipFill>
+          <a:blip r:embed="rId2"/>
+          <a:stretch>
+            <a:fillRect/>
+          </a:stretch>
+        </p:blipFill>
         <p:spPr>
           <a:xfrm>
             <a:off x="0" y="0"/>
@@ -5559,8 +5491,26 @@
           <a:prstGeom prst="rect">
             <a:avLst/>
           </a:prstGeom>
+        </p:spPr>
+      </p:pic>
+      <p:sp>
+        <p:nvSpPr>
+          <p:cNvPr id="3" name="Rectangle 2"/>
+          <p:cNvSpPr/>
+          <p:nvPr/>
+        </p:nvSpPr>
+        <p:spPr>
+          <a:xfrm>
+            <a:off x="0" y="0"/>
+            <a:ext cx="12191695" cy="6858000"/>
+          </a:xfrm>
+          <a:prstGeom prst="rect">
+            <a:avLst/>
+          </a:prstGeom>
           <a:solidFill>
-            <a:srgbClr val="1B2838"/>
+            <a:srgbClr val="1B2838">
+              <a:alpha val="75000"/>
+            </a:srgbClr>
           </a:solidFill>
           <a:ln>
             <a:noFill/>
@@ -5590,14 +5540,14 @@
       </p:sp>
       <p:sp>
         <p:nvSpPr>
-          <p:cNvPr id="3" name="TextBox 2"/>
+          <p:cNvPr id="4" name="TextBox 3"/>
           <p:cNvSpPr txBox="1"/>
           <p:nvPr/>
         </p:nvSpPr>
         <p:spPr>
           <a:xfrm>
-            <a:off x="457200" y="365760"/>
-            <a:ext cx="10972800" cy="548640"/>
+            <a:off x="457200" y="274320"/>
+            <a:ext cx="3657600" cy="365760"/>
           </a:xfrm>
           <a:prstGeom prst="rect">
             <a:avLst/>
@@ -5610,21 +5560,21 @@
           </a:bodyPr>
           <a:lstStyle/>
           <a:p>
-            <a:pPr algn="ctr"/>
-            <a:r>
-              <a:rPr sz="1800" b="0">
-                <a:solidFill>
-                  <a:srgbClr val="ECF0F1"/>
+            <a:pPr algn="l"/>
+            <a:r>
+              <a:rPr sz="1100" b="1">
+                <a:solidFill>
+                  <a:srgbClr val="F39C12"/>
                 </a:solidFill>
               </a:rPr>
-              <a:t>The Challenge &amp; Our Answer</a:t>
-            </a:r>
-          </a:p>
-        </p:txBody>
-      </p:sp>
-      <p:sp>
-        <p:nvSpPr>
-          <p:cNvPr id="4" name="Rounded Rectangle 3"/>
+              <a:t>THE CHALLENGE &amp; SOLUTION</a:t>
+            </a:r>
+          </a:p>
+        </p:txBody>
+      </p:sp>
+      <p:sp>
+        <p:nvSpPr>
+          <p:cNvPr id="5" name="Rounded Rectangle 4"/>
           <p:cNvSpPr/>
           <p:nvPr/>
         </p:nvSpPr>
@@ -5667,7 +5617,7 @@
       </p:sp>
       <p:sp>
         <p:nvSpPr>
-          <p:cNvPr id="5" name="Rectangle 4"/>
+          <p:cNvPr id="6" name="Rectangle 5"/>
           <p:cNvSpPr/>
           <p:nvPr/>
         </p:nvSpPr>
@@ -5710,14 +5660,14 @@
       </p:sp>
       <p:sp>
         <p:nvSpPr>
-          <p:cNvPr id="6" name="TextBox 5"/>
+          <p:cNvPr id="7" name="TextBox 6"/>
           <p:cNvSpPr txBox="1"/>
           <p:nvPr/>
         </p:nvSpPr>
         <p:spPr>
           <a:xfrm>
-            <a:off x="1188720" y="1828800"/>
-            <a:ext cx="3840480" cy="1097280"/>
+            <a:off x="1188720" y="1737360"/>
+            <a:ext cx="3840480" cy="457200"/>
           </a:xfrm>
           <a:prstGeom prst="rect">
             <a:avLst/>
@@ -5732,25 +5682,25 @@
           <a:p>
             <a:pPr algn="ctr"/>
             <a:r>
-              <a:rPr sz="4800" b="0">
-                <a:solidFill>
-                  <a:srgbClr val="FFFFFF"/>
+              <a:rPr sz="1200" b="1">
+                <a:solidFill>
+                  <a:srgbClr val="E74C3C"/>
                 </a:solidFill>
               </a:rPr>
-              <a:t>🤷</a:t>
-            </a:r>
-          </a:p>
-        </p:txBody>
-      </p:sp>
-      <p:sp>
-        <p:nvSpPr>
-          <p:cNvPr id="7" name="TextBox 6"/>
+              <a:t>THE PROBLEM</a:t>
+            </a:r>
+          </a:p>
+        </p:txBody>
+      </p:sp>
+      <p:sp>
+        <p:nvSpPr>
+          <p:cNvPr id="8" name="TextBox 7"/>
           <p:cNvSpPr txBox="1"/>
           <p:nvPr/>
         </p:nvSpPr>
         <p:spPr>
           <a:xfrm>
-            <a:off x="1188720" y="3017520"/>
+            <a:off x="1188720" y="2468880"/>
             <a:ext cx="3840480" cy="640080"/>
           </a:xfrm>
           <a:prstGeom prst="rect">
@@ -5766,7 +5716,7 @@
           <a:p>
             <a:pPr algn="ctr"/>
             <a:r>
-              <a:rPr sz="2400" b="1">
+              <a:rPr sz="2600" b="1">
                 <a:solidFill>
                   <a:srgbClr val="FFFFFF"/>
                 </a:solidFill>
@@ -5778,13 +5728,13 @@
       </p:sp>
       <p:sp>
         <p:nvSpPr>
-          <p:cNvPr id="8" name="TextBox 7"/>
+          <p:cNvPr id="9" name="TextBox 8"/>
           <p:cNvSpPr txBox="1"/>
           <p:nvPr/>
         </p:nvSpPr>
         <p:spPr>
           <a:xfrm>
-            <a:off x="1188720" y="3840480"/>
+            <a:off x="1188720" y="3383280"/>
             <a:ext cx="3840480" cy="1371600"/>
           </a:xfrm>
           <a:prstGeom prst="rect">
@@ -5812,7 +5762,7 @@
       </p:sp>
       <p:sp>
         <p:nvSpPr>
-          <p:cNvPr id="9" name="TextBox 8"/>
+          <p:cNvPr id="10" name="TextBox 9"/>
           <p:cNvSpPr txBox="1"/>
           <p:nvPr/>
         </p:nvSpPr>
@@ -5846,7 +5796,7 @@
       </p:sp>
       <p:sp>
         <p:nvSpPr>
-          <p:cNvPr id="10" name="Rounded Rectangle 9"/>
+          <p:cNvPr id="11" name="Rounded Rectangle 10"/>
           <p:cNvSpPr/>
           <p:nvPr/>
         </p:nvSpPr>
@@ -5889,7 +5839,7 @@
       </p:sp>
       <p:sp>
         <p:nvSpPr>
-          <p:cNvPr id="11" name="Rectangle 10"/>
+          <p:cNvPr id="12" name="Rectangle 11"/>
           <p:cNvSpPr/>
           <p:nvPr/>
         </p:nvSpPr>
@@ -5932,14 +5882,14 @@
       </p:sp>
       <p:sp>
         <p:nvSpPr>
-          <p:cNvPr id="12" name="TextBox 11"/>
+          <p:cNvPr id="13" name="TextBox 12"/>
           <p:cNvSpPr txBox="1"/>
           <p:nvPr/>
         </p:nvSpPr>
         <p:spPr>
           <a:xfrm>
-            <a:off x="7040880" y="1828800"/>
-            <a:ext cx="3840480" cy="1097280"/>
+            <a:off x="7040880" y="1737360"/>
+            <a:ext cx="3840480" cy="457200"/>
           </a:xfrm>
           <a:prstGeom prst="rect">
             <a:avLst/>
@@ -5954,25 +5904,25 @@
           <a:p>
             <a:pPr algn="ctr"/>
             <a:r>
-              <a:rPr sz="4800" b="0">
-                <a:solidFill>
-                  <a:srgbClr val="FFFFFF"/>
+              <a:rPr sz="1200" b="1">
+                <a:solidFill>
+                  <a:srgbClr val="2ECC71"/>
                 </a:solidFill>
               </a:rPr>
-              <a:t>👨‍🍳</a:t>
-            </a:r>
-          </a:p>
-        </p:txBody>
-      </p:sp>
-      <p:sp>
-        <p:nvSpPr>
-          <p:cNvPr id="13" name="TextBox 12"/>
+              <a:t>THE SOLUTION</a:t>
+            </a:r>
+          </a:p>
+        </p:txBody>
+      </p:sp>
+      <p:sp>
+        <p:nvSpPr>
+          <p:cNvPr id="14" name="TextBox 13"/>
           <p:cNvSpPr txBox="1"/>
           <p:nvPr/>
         </p:nvSpPr>
         <p:spPr>
           <a:xfrm>
-            <a:off x="7040880" y="3017520"/>
+            <a:off x="7040880" y="2468880"/>
             <a:ext cx="3840480" cy="640080"/>
           </a:xfrm>
           <a:prstGeom prst="rect">
@@ -5988,7 +5938,7 @@
           <a:p>
             <a:pPr algn="ctr"/>
             <a:r>
-              <a:rPr sz="2400" b="1">
+              <a:rPr sz="2600" b="1">
                 <a:solidFill>
                   <a:srgbClr val="2ECC71"/>
                 </a:solidFill>
@@ -6000,13 +5950,13 @@
       </p:sp>
       <p:sp>
         <p:nvSpPr>
-          <p:cNvPr id="14" name="TextBox 13"/>
+          <p:cNvPr id="15" name="TextBox 14"/>
           <p:cNvSpPr txBox="1"/>
           <p:nvPr/>
         </p:nvSpPr>
         <p:spPr>
           <a:xfrm>
-            <a:off x="7040880" y="3840480"/>
+            <a:off x="7040880" y="3383280"/>
             <a:ext cx="3840480" cy="1371600"/>
           </a:xfrm>
           <a:prstGeom prst="rect">
@@ -6034,7 +5984,7 @@
       </p:sp>
       <p:sp>
         <p:nvSpPr>
-          <p:cNvPr id="15" name="TextBox 14"/>
+          <p:cNvPr id="16" name="TextBox 15"/>
           <p:cNvSpPr txBox="1"/>
           <p:nvPr/>
         </p:nvSpPr>
@@ -6084,12 +6034,20 @@
         <p:nvPr/>
       </p:nvGrpSpPr>
       <p:grpSpPr/>
-      <p:sp>
-        <p:nvSpPr>
-          <p:cNvPr id="2" name="Rectangle 1"/>
-          <p:cNvSpPr/>
-          <p:nvPr/>
-        </p:nvSpPr>
+      <p:pic>
+        <p:nvPicPr>
+          <p:cNvPr id="2" name="Picture 1" descr="06_app.jpg"/>
+          <p:cNvPicPr>
+            <a:picLocks noChangeAspect="1"/>
+          </p:cNvPicPr>
+          <p:nvPr/>
+        </p:nvPicPr>
+        <p:blipFill>
+          <a:blip r:embed="rId2"/>
+          <a:stretch>
+            <a:fillRect/>
+          </a:stretch>
+        </p:blipFill>
         <p:spPr>
           <a:xfrm>
             <a:off x="0" y="0"/>
@@ -6098,8 +6056,26 @@
           <a:prstGeom prst="rect">
             <a:avLst/>
           </a:prstGeom>
+        </p:spPr>
+      </p:pic>
+      <p:sp>
+        <p:nvSpPr>
+          <p:cNvPr id="3" name="Rectangle 2"/>
+          <p:cNvSpPr/>
+          <p:nvPr/>
+        </p:nvSpPr>
+        <p:spPr>
+          <a:xfrm>
+            <a:off x="0" y="0"/>
+            <a:ext cx="12191695" cy="6858000"/>
+          </a:xfrm>
+          <a:prstGeom prst="rect">
+            <a:avLst/>
+          </a:prstGeom>
           <a:solidFill>
-            <a:srgbClr val="1B2838"/>
+            <a:srgbClr val="1B2838">
+              <a:alpha val="75000"/>
+            </a:srgbClr>
           </a:solidFill>
           <a:ln>
             <a:noFill/>
@@ -6129,14 +6105,14 @@
       </p:sp>
       <p:sp>
         <p:nvSpPr>
-          <p:cNvPr id="3" name="TextBox 2"/>
+          <p:cNvPr id="4" name="TextBox 3"/>
           <p:cNvSpPr txBox="1"/>
           <p:nvPr/>
         </p:nvSpPr>
         <p:spPr>
           <a:xfrm>
-            <a:off x="457200" y="365760"/>
-            <a:ext cx="10972800" cy="914400"/>
+            <a:off x="457200" y="274320"/>
+            <a:ext cx="3657600" cy="365760"/>
           </a:xfrm>
           <a:prstGeom prst="rect">
             <a:avLst/>
@@ -6149,6 +6125,40 @@
           </a:bodyPr>
           <a:lstStyle/>
           <a:p>
+            <a:pPr algn="l"/>
+            <a:r>
+              <a:rPr sz="1100" b="1">
+                <a:solidFill>
+                  <a:srgbClr val="F39C12"/>
+                </a:solidFill>
+              </a:rPr>
+              <a:t>FEATURES</a:t>
+            </a:r>
+          </a:p>
+        </p:txBody>
+      </p:sp>
+      <p:sp>
+        <p:nvSpPr>
+          <p:cNvPr id="5" name="TextBox 4"/>
+          <p:cNvSpPr txBox="1"/>
+          <p:nvPr/>
+        </p:nvSpPr>
+        <p:spPr>
+          <a:xfrm>
+            <a:off x="457200" y="731520"/>
+            <a:ext cx="10972800" cy="914400"/>
+          </a:xfrm>
+          <a:prstGeom prst="rect">
+            <a:avLst/>
+          </a:prstGeom>
+          <a:noFill/>
+        </p:spPr>
+        <p:txBody>
+          <a:bodyPr wrap="square">
+            <a:spAutoFit/>
+          </a:bodyPr>
+          <a:lstStyle/>
+          <a:p>
             <a:pPr algn="ctr"/>
             <a:r>
               <a:rPr sz="3600" b="1">
@@ -6163,14 +6173,14 @@
       </p:sp>
       <p:sp>
         <p:nvSpPr>
-          <p:cNvPr id="4" name="Rounded Rectangle 3"/>
+          <p:cNvPr id="6" name="Rounded Rectangle 5"/>
           <p:cNvSpPr/>
           <p:nvPr/>
         </p:nvSpPr>
         <p:spPr>
           <a:xfrm>
-            <a:off x="822960" y="1645920"/>
-            <a:ext cx="3291840" cy="2194560"/>
+            <a:off x="822960" y="1828800"/>
+            <a:ext cx="3291840" cy="2011680"/>
           </a:xfrm>
           <a:prstGeom prst="roundRect">
             <a:avLst/>
@@ -6206,13 +6216,13 @@
       </p:sp>
       <p:sp>
         <p:nvSpPr>
-          <p:cNvPr id="5" name="Rectangle 4"/>
+          <p:cNvPr id="7" name="Rectangle 6"/>
           <p:cNvSpPr/>
           <p:nvPr/>
         </p:nvSpPr>
         <p:spPr>
           <a:xfrm>
-            <a:off x="822960" y="1645920"/>
+            <a:off x="822960" y="1828800"/>
             <a:ext cx="3291840" cy="73152"/>
           </a:xfrm>
           <a:prstGeom prst="rect">
@@ -6249,13 +6259,13 @@
       </p:sp>
       <p:sp>
         <p:nvSpPr>
-          <p:cNvPr id="6" name="TextBox 5"/>
+          <p:cNvPr id="8" name="TextBox 7"/>
           <p:cNvSpPr txBox="1"/>
           <p:nvPr/>
         </p:nvSpPr>
         <p:spPr>
           <a:xfrm>
-            <a:off x="1005840" y="1920240"/>
+            <a:off x="1005840" y="2286000"/>
             <a:ext cx="2926080" cy="731520"/>
           </a:xfrm>
           <a:prstGeom prst="rect">
@@ -6271,26 +6281,26 @@
           <a:p>
             <a:pPr algn="ctr"/>
             <a:r>
-              <a:rPr sz="3600" b="0">
+              <a:rPr sz="1800" b="1">
                 <a:solidFill>
                   <a:srgbClr val="FFFFFF"/>
                 </a:solidFill>
               </a:rPr>
-              <a:t>🔔</a:t>
-            </a:r>
-          </a:p>
-        </p:txBody>
-      </p:sp>
-      <p:sp>
-        <p:nvSpPr>
-          <p:cNvPr id="7" name="TextBox 6"/>
+              <a:t>Smart Expiry Alerts</a:t>
+            </a:r>
+          </a:p>
+        </p:txBody>
+      </p:sp>
+      <p:sp>
+        <p:nvSpPr>
+          <p:cNvPr id="9" name="TextBox 8"/>
           <p:cNvSpPr txBox="1"/>
           <p:nvPr/>
         </p:nvSpPr>
         <p:spPr>
           <a:xfrm>
-            <a:off x="1005840" y="2651760"/>
-            <a:ext cx="2926080" cy="548640"/>
+            <a:off x="1005840" y="3017520"/>
+            <a:ext cx="2926080" cy="640080"/>
           </a:xfrm>
           <a:prstGeom prst="rect">
             <a:avLst/>
@@ -6305,41 +6315,7 @@
           <a:p>
             <a:pPr algn="ctr"/>
             <a:r>
-              <a:rPr sz="1600" b="1">
-                <a:solidFill>
-                  <a:srgbClr val="FFFFFF"/>
-                </a:solidFill>
-              </a:rPr>
-              <a:t>Smart Expiry Alerts</a:t>
-            </a:r>
-          </a:p>
-        </p:txBody>
-      </p:sp>
-      <p:sp>
-        <p:nvSpPr>
-          <p:cNvPr id="8" name="TextBox 7"/>
-          <p:cNvSpPr txBox="1"/>
-          <p:nvPr/>
-        </p:nvSpPr>
-        <p:spPr>
-          <a:xfrm>
-            <a:off x="1005840" y="3200400"/>
-            <a:ext cx="2926080" cy="457200"/>
-          </a:xfrm>
-          <a:prstGeom prst="rect">
-            <a:avLst/>
-          </a:prstGeom>
-          <a:noFill/>
-        </p:spPr>
-        <p:txBody>
-          <a:bodyPr wrap="square">
-            <a:spAutoFit/>
-          </a:bodyPr>
-          <a:lstStyle/>
-          <a:p>
-            <a:pPr algn="ctr"/>
-            <a:r>
-              <a:rPr sz="1200" b="0">
+              <a:rPr sz="1300" b="0">
                 <a:solidFill>
                   <a:srgbClr val="ECF0F1"/>
                 </a:solidFill>
@@ -6351,14 +6327,14 @@
       </p:sp>
       <p:sp>
         <p:nvSpPr>
-          <p:cNvPr id="9" name="Rounded Rectangle 8"/>
+          <p:cNvPr id="10" name="Rounded Rectangle 9"/>
           <p:cNvSpPr/>
           <p:nvPr/>
         </p:nvSpPr>
         <p:spPr>
           <a:xfrm>
-            <a:off x="4480560" y="1645920"/>
-            <a:ext cx="3291840" cy="2194560"/>
+            <a:off x="4480560" y="1828800"/>
+            <a:ext cx="3291840" cy="2011680"/>
           </a:xfrm>
           <a:prstGeom prst="roundRect">
             <a:avLst/>
@@ -6394,13 +6370,13 @@
       </p:sp>
       <p:sp>
         <p:nvSpPr>
-          <p:cNvPr id="10" name="Rectangle 9"/>
+          <p:cNvPr id="11" name="Rectangle 10"/>
           <p:cNvSpPr/>
           <p:nvPr/>
         </p:nvSpPr>
         <p:spPr>
           <a:xfrm>
-            <a:off x="4480560" y="1645920"/>
+            <a:off x="4480560" y="1828800"/>
             <a:ext cx="3291840" cy="73152"/>
           </a:xfrm>
           <a:prstGeom prst="rect">
@@ -6437,13 +6413,13 @@
       </p:sp>
       <p:sp>
         <p:nvSpPr>
-          <p:cNvPr id="11" name="TextBox 10"/>
+          <p:cNvPr id="12" name="TextBox 11"/>
           <p:cNvSpPr txBox="1"/>
           <p:nvPr/>
         </p:nvSpPr>
         <p:spPr>
           <a:xfrm>
-            <a:off x="4663440" y="1920240"/>
+            <a:off x="4663440" y="2286000"/>
             <a:ext cx="2926080" cy="731520"/>
           </a:xfrm>
           <a:prstGeom prst="rect">
@@ -6459,26 +6435,26 @@
           <a:p>
             <a:pPr algn="ctr"/>
             <a:r>
-              <a:rPr sz="3600" b="0">
+              <a:rPr sz="1800" b="1">
                 <a:solidFill>
                   <a:srgbClr val="FFFFFF"/>
                 </a:solidFill>
               </a:rPr>
-              <a:t>🧑‍🍳</a:t>
-            </a:r>
-          </a:p>
-        </p:txBody>
-      </p:sp>
-      <p:sp>
-        <p:nvSpPr>
-          <p:cNvPr id="12" name="TextBox 11"/>
+              <a:t>AI Recipe Suggestions</a:t>
+            </a:r>
+          </a:p>
+        </p:txBody>
+      </p:sp>
+      <p:sp>
+        <p:nvSpPr>
+          <p:cNvPr id="13" name="TextBox 12"/>
           <p:cNvSpPr txBox="1"/>
           <p:nvPr/>
         </p:nvSpPr>
         <p:spPr>
           <a:xfrm>
-            <a:off x="4663440" y="2651760"/>
-            <a:ext cx="2926080" cy="548640"/>
+            <a:off x="4663440" y="3017520"/>
+            <a:ext cx="2926080" cy="640080"/>
           </a:xfrm>
           <a:prstGeom prst="rect">
             <a:avLst/>
@@ -6493,41 +6469,7 @@
           <a:p>
             <a:pPr algn="ctr"/>
             <a:r>
-              <a:rPr sz="1600" b="1">
-                <a:solidFill>
-                  <a:srgbClr val="FFFFFF"/>
-                </a:solidFill>
-              </a:rPr>
-              <a:t>AI Recipe Suggestions</a:t>
-            </a:r>
-          </a:p>
-        </p:txBody>
-      </p:sp>
-      <p:sp>
-        <p:nvSpPr>
-          <p:cNvPr id="13" name="TextBox 12"/>
-          <p:cNvSpPr txBox="1"/>
-          <p:nvPr/>
-        </p:nvSpPr>
-        <p:spPr>
-          <a:xfrm>
-            <a:off x="4663440" y="3200400"/>
-            <a:ext cx="2926080" cy="457200"/>
-          </a:xfrm>
-          <a:prstGeom prst="rect">
-            <a:avLst/>
-          </a:prstGeom>
-          <a:noFill/>
-        </p:spPr>
-        <p:txBody>
-          <a:bodyPr wrap="square">
-            <a:spAutoFit/>
-          </a:bodyPr>
-          <a:lstStyle/>
-          <a:p>
-            <a:pPr algn="ctr"/>
-            <a:r>
-              <a:rPr sz="1200" b="0">
+              <a:rPr sz="1300" b="0">
                 <a:solidFill>
                   <a:srgbClr val="ECF0F1"/>
                 </a:solidFill>
@@ -6545,8 +6487,8 @@
         </p:nvSpPr>
         <p:spPr>
           <a:xfrm>
-            <a:off x="8138160" y="1645920"/>
-            <a:ext cx="3291840" cy="2194560"/>
+            <a:off x="8138160" y="1828800"/>
+            <a:ext cx="3291840" cy="2011680"/>
           </a:xfrm>
           <a:prstGeom prst="roundRect">
             <a:avLst/>
@@ -6588,7 +6530,7 @@
         </p:nvSpPr>
         <p:spPr>
           <a:xfrm>
-            <a:off x="8138160" y="1645920"/>
+            <a:off x="8138160" y="1828800"/>
             <a:ext cx="3291840" cy="73152"/>
           </a:xfrm>
           <a:prstGeom prst="rect">
@@ -6631,7 +6573,7 @@
         </p:nvSpPr>
         <p:spPr>
           <a:xfrm>
-            <a:off x="8321040" y="1920240"/>
+            <a:off x="8321040" y="2286000"/>
             <a:ext cx="2926080" cy="731520"/>
           </a:xfrm>
           <a:prstGeom prst="rect">
@@ -6647,12 +6589,12 @@
           <a:p>
             <a:pPr algn="ctr"/>
             <a:r>
-              <a:rPr sz="3600" b="0">
+              <a:rPr sz="1800" b="1">
                 <a:solidFill>
                   <a:srgbClr val="FFFFFF"/>
                 </a:solidFill>
               </a:rPr>
-              <a:t>🫂</a:t>
+              <a:t>Community Food Sharing</a:t>
             </a:r>
           </a:p>
         </p:txBody>
@@ -6665,8 +6607,8 @@
         </p:nvSpPr>
         <p:spPr>
           <a:xfrm>
-            <a:off x="8321040" y="2651760"/>
-            <a:ext cx="2926080" cy="548640"/>
+            <a:off x="8321040" y="3017520"/>
+            <a:ext cx="2926080" cy="640080"/>
           </a:xfrm>
           <a:prstGeom prst="rect">
             <a:avLst/>
@@ -6681,41 +6623,7 @@
           <a:p>
             <a:pPr algn="ctr"/>
             <a:r>
-              <a:rPr sz="1600" b="1">
-                <a:solidFill>
-                  <a:srgbClr val="FFFFFF"/>
-                </a:solidFill>
-              </a:rPr>
-              <a:t>Community Food Sharing</a:t>
-            </a:r>
-          </a:p>
-        </p:txBody>
-      </p:sp>
-      <p:sp>
-        <p:nvSpPr>
-          <p:cNvPr id="18" name="TextBox 17"/>
-          <p:cNvSpPr txBox="1"/>
-          <p:nvPr/>
-        </p:nvSpPr>
-        <p:spPr>
-          <a:xfrm>
-            <a:off x="8321040" y="3200400"/>
-            <a:ext cx="2926080" cy="457200"/>
-          </a:xfrm>
-          <a:prstGeom prst="rect">
-            <a:avLst/>
-          </a:prstGeom>
-          <a:noFill/>
-        </p:spPr>
-        <p:txBody>
-          <a:bodyPr wrap="square">
-            <a:spAutoFit/>
-          </a:bodyPr>
-          <a:lstStyle/>
-          <a:p>
-            <a:pPr algn="ctr"/>
-            <a:r>
-              <a:rPr sz="1200" b="0">
+              <a:rPr sz="1300" b="0">
                 <a:solidFill>
                   <a:srgbClr val="ECF0F1"/>
                 </a:solidFill>
@@ -6727,14 +6635,14 @@
       </p:sp>
       <p:sp>
         <p:nvSpPr>
-          <p:cNvPr id="19" name="Rounded Rectangle 18"/>
+          <p:cNvPr id="18" name="Rounded Rectangle 17"/>
           <p:cNvSpPr/>
           <p:nvPr/>
         </p:nvSpPr>
         <p:spPr>
           <a:xfrm>
             <a:off x="822960" y="4206240"/>
-            <a:ext cx="3291840" cy="2194560"/>
+            <a:ext cx="3291840" cy="2011680"/>
           </a:xfrm>
           <a:prstGeom prst="roundRect">
             <a:avLst/>
@@ -6770,7 +6678,7 @@
       </p:sp>
       <p:sp>
         <p:nvSpPr>
-          <p:cNvPr id="20" name="Rectangle 19"/>
+          <p:cNvPr id="19" name="Rectangle 18"/>
           <p:cNvSpPr/>
           <p:nvPr/>
         </p:nvSpPr>
@@ -6813,13 +6721,13 @@
       </p:sp>
       <p:sp>
         <p:nvSpPr>
-          <p:cNvPr id="21" name="TextBox 20"/>
+          <p:cNvPr id="20" name="TextBox 19"/>
           <p:cNvSpPr txBox="1"/>
           <p:nvPr/>
         </p:nvSpPr>
         <p:spPr>
           <a:xfrm>
-            <a:off x="1005840" y="4480560"/>
+            <a:off x="1005840" y="4663440"/>
             <a:ext cx="2926080" cy="731520"/>
           </a:xfrm>
           <a:prstGeom prst="rect">
@@ -6835,26 +6743,26 @@
           <a:p>
             <a:pPr algn="ctr"/>
             <a:r>
-              <a:rPr sz="3600" b="0">
+              <a:rPr sz="1800" b="1">
                 <a:solidFill>
                   <a:srgbClr val="FFFFFF"/>
                 </a:solidFill>
               </a:rPr>
-              <a:t>📊</a:t>
-            </a:r>
-          </a:p>
-        </p:txBody>
-      </p:sp>
-      <p:sp>
-        <p:nvSpPr>
-          <p:cNvPr id="22" name="TextBox 21"/>
+              <a:t>Waste Analytics Dashboard</a:t>
+            </a:r>
+          </a:p>
+        </p:txBody>
+      </p:sp>
+      <p:sp>
+        <p:nvSpPr>
+          <p:cNvPr id="21" name="TextBox 20"/>
           <p:cNvSpPr txBox="1"/>
           <p:nvPr/>
         </p:nvSpPr>
         <p:spPr>
           <a:xfrm>
-            <a:off x="1005840" y="5212080"/>
-            <a:ext cx="2926080" cy="548640"/>
+            <a:off x="1005840" y="5394960"/>
+            <a:ext cx="2926080" cy="640080"/>
           </a:xfrm>
           <a:prstGeom prst="rect">
             <a:avLst/>
@@ -6869,41 +6777,7 @@
           <a:p>
             <a:pPr algn="ctr"/>
             <a:r>
-              <a:rPr sz="1600" b="1">
-                <a:solidFill>
-                  <a:srgbClr val="FFFFFF"/>
-                </a:solidFill>
-              </a:rPr>
-              <a:t>Waste Analytics Dashboard</a:t>
-            </a:r>
-          </a:p>
-        </p:txBody>
-      </p:sp>
-      <p:sp>
-        <p:nvSpPr>
-          <p:cNvPr id="23" name="TextBox 22"/>
-          <p:cNvSpPr txBox="1"/>
-          <p:nvPr/>
-        </p:nvSpPr>
-        <p:spPr>
-          <a:xfrm>
-            <a:off x="1005840" y="5760720"/>
-            <a:ext cx="2926080" cy="457200"/>
-          </a:xfrm>
-          <a:prstGeom prst="rect">
-            <a:avLst/>
-          </a:prstGeom>
-          <a:noFill/>
-        </p:spPr>
-        <p:txBody>
-          <a:bodyPr wrap="square">
-            <a:spAutoFit/>
-          </a:bodyPr>
-          <a:lstStyle/>
-          <a:p>
-            <a:pPr algn="ctr"/>
-            <a:r>
-              <a:rPr sz="1200" b="0">
+              <a:rPr sz="1300" b="0">
                 <a:solidFill>
                   <a:srgbClr val="ECF0F1"/>
                 </a:solidFill>
@@ -6915,14 +6789,14 @@
       </p:sp>
       <p:sp>
         <p:nvSpPr>
-          <p:cNvPr id="24" name="Rounded Rectangle 23"/>
+          <p:cNvPr id="22" name="Rounded Rectangle 21"/>
           <p:cNvSpPr/>
           <p:nvPr/>
         </p:nvSpPr>
         <p:spPr>
           <a:xfrm>
             <a:off x="4480560" y="4206240"/>
-            <a:ext cx="3291840" cy="2194560"/>
+            <a:ext cx="3291840" cy="2011680"/>
           </a:xfrm>
           <a:prstGeom prst="roundRect">
             <a:avLst/>
@@ -6958,7 +6832,7 @@
       </p:sp>
       <p:sp>
         <p:nvSpPr>
-          <p:cNvPr id="25" name="Rectangle 24"/>
+          <p:cNvPr id="23" name="Rectangle 22"/>
           <p:cNvSpPr/>
           <p:nvPr/>
         </p:nvSpPr>
@@ -7001,13 +6875,13 @@
       </p:sp>
       <p:sp>
         <p:nvSpPr>
-          <p:cNvPr id="26" name="TextBox 25"/>
+          <p:cNvPr id="24" name="TextBox 23"/>
           <p:cNvSpPr txBox="1"/>
           <p:nvPr/>
         </p:nvSpPr>
         <p:spPr>
           <a:xfrm>
-            <a:off x="4663440" y="4480560"/>
+            <a:off x="4663440" y="4663440"/>
             <a:ext cx="2926080" cy="731520"/>
           </a:xfrm>
           <a:prstGeom prst="rect">
@@ -7023,26 +6897,26 @@
           <a:p>
             <a:pPr algn="ctr"/>
             <a:r>
-              <a:rPr sz="3600" b="0">
+              <a:rPr sz="1800" b="1">
                 <a:solidFill>
                   <a:srgbClr val="FFFFFF"/>
                 </a:solidFill>
               </a:rPr>
-              <a:t>❤️</a:t>
-            </a:r>
-          </a:p>
-        </p:txBody>
-      </p:sp>
-      <p:sp>
-        <p:nvSpPr>
-          <p:cNvPr id="27" name="TextBox 26"/>
+              <a:t>Donation Network</a:t>
+            </a:r>
+          </a:p>
+        </p:txBody>
+      </p:sp>
+      <p:sp>
+        <p:nvSpPr>
+          <p:cNvPr id="25" name="TextBox 24"/>
           <p:cNvSpPr txBox="1"/>
           <p:nvPr/>
         </p:nvSpPr>
         <p:spPr>
           <a:xfrm>
-            <a:off x="4663440" y="5212080"/>
-            <a:ext cx="2926080" cy="548640"/>
+            <a:off x="4663440" y="5394960"/>
+            <a:ext cx="2926080" cy="640080"/>
           </a:xfrm>
           <a:prstGeom prst="rect">
             <a:avLst/>
@@ -7057,41 +6931,7 @@
           <a:p>
             <a:pPr algn="ctr"/>
             <a:r>
-              <a:rPr sz="1600" b="1">
-                <a:solidFill>
-                  <a:srgbClr val="FFFFFF"/>
-                </a:solidFill>
-              </a:rPr>
-              <a:t>Donation Network</a:t>
-            </a:r>
-          </a:p>
-        </p:txBody>
-      </p:sp>
-      <p:sp>
-        <p:nvSpPr>
-          <p:cNvPr id="28" name="TextBox 27"/>
-          <p:cNvSpPr txBox="1"/>
-          <p:nvPr/>
-        </p:nvSpPr>
-        <p:spPr>
-          <a:xfrm>
-            <a:off x="4663440" y="5760720"/>
-            <a:ext cx="2926080" cy="457200"/>
-          </a:xfrm>
-          <a:prstGeom prst="rect">
-            <a:avLst/>
-          </a:prstGeom>
-          <a:noFill/>
-        </p:spPr>
-        <p:txBody>
-          <a:bodyPr wrap="square">
-            <a:spAutoFit/>
-          </a:bodyPr>
-          <a:lstStyle/>
-          <a:p>
-            <a:pPr algn="ctr"/>
-            <a:r>
-              <a:rPr sz="1200" b="0">
+              <a:rPr sz="1300" b="0">
                 <a:solidFill>
                   <a:srgbClr val="ECF0F1"/>
                 </a:solidFill>
@@ -7103,14 +6943,14 @@
       </p:sp>
       <p:sp>
         <p:nvSpPr>
-          <p:cNvPr id="29" name="Rounded Rectangle 28"/>
+          <p:cNvPr id="26" name="Rounded Rectangle 25"/>
           <p:cNvSpPr/>
           <p:nvPr/>
         </p:nvSpPr>
         <p:spPr>
           <a:xfrm>
             <a:off x="8138160" y="4206240"/>
-            <a:ext cx="3291840" cy="2194560"/>
+            <a:ext cx="3291840" cy="2011680"/>
           </a:xfrm>
           <a:prstGeom prst="roundRect">
             <a:avLst/>
@@ -7146,7 +6986,7 @@
       </p:sp>
       <p:sp>
         <p:nvSpPr>
-          <p:cNvPr id="30" name="Rectangle 29"/>
+          <p:cNvPr id="27" name="Rectangle 26"/>
           <p:cNvSpPr/>
           <p:nvPr/>
         </p:nvSpPr>
@@ -7189,13 +7029,13 @@
       </p:sp>
       <p:sp>
         <p:nvSpPr>
-          <p:cNvPr id="31" name="TextBox 30"/>
+          <p:cNvPr id="28" name="TextBox 27"/>
           <p:cNvSpPr txBox="1"/>
           <p:nvPr/>
         </p:nvSpPr>
         <p:spPr>
           <a:xfrm>
-            <a:off x="8321040" y="4480560"/>
+            <a:off x="8321040" y="4663440"/>
             <a:ext cx="2926080" cy="731520"/>
           </a:xfrm>
           <a:prstGeom prst="rect">
@@ -7211,26 +7051,26 @@
           <a:p>
             <a:pPr algn="ctr"/>
             <a:r>
-              <a:rPr sz="3600" b="0">
+              <a:rPr sz="1800" b="1">
                 <a:solidFill>
                   <a:srgbClr val="FFFFFF"/>
                 </a:solidFill>
               </a:rPr>
-              <a:t>📱</a:t>
-            </a:r>
-          </a:p>
-        </p:txBody>
-      </p:sp>
-      <p:sp>
-        <p:nvSpPr>
-          <p:cNvPr id="32" name="TextBox 31"/>
+              <a:t>Multi-platform Access</a:t>
+            </a:r>
+          </a:p>
+        </p:txBody>
+      </p:sp>
+      <p:sp>
+        <p:nvSpPr>
+          <p:cNvPr id="29" name="TextBox 28"/>
           <p:cNvSpPr txBox="1"/>
           <p:nvPr/>
         </p:nvSpPr>
         <p:spPr>
           <a:xfrm>
-            <a:off x="8321040" y="5212080"/>
-            <a:ext cx="2926080" cy="548640"/>
+            <a:off x="8321040" y="5394960"/>
+            <a:ext cx="2926080" cy="640080"/>
           </a:xfrm>
           <a:prstGeom prst="rect">
             <a:avLst/>
@@ -7245,41 +7085,7 @@
           <a:p>
             <a:pPr algn="ctr"/>
             <a:r>
-              <a:rPr sz="1600" b="1">
-                <a:solidFill>
-                  <a:srgbClr val="FFFFFF"/>
-                </a:solidFill>
-              </a:rPr>
-              <a:t>Multi-platform Access</a:t>
-            </a:r>
-          </a:p>
-        </p:txBody>
-      </p:sp>
-      <p:sp>
-        <p:nvSpPr>
-          <p:cNvPr id="33" name="TextBox 32"/>
-          <p:cNvSpPr txBox="1"/>
-          <p:nvPr/>
-        </p:nvSpPr>
-        <p:spPr>
-          <a:xfrm>
-            <a:off x="8321040" y="5760720"/>
-            <a:ext cx="2926080" cy="457200"/>
-          </a:xfrm>
-          <a:prstGeom prst="rect">
-            <a:avLst/>
-          </a:prstGeom>
-          <a:noFill/>
-        </p:spPr>
-        <p:txBody>
-          <a:bodyPr wrap="square">
-            <a:spAutoFit/>
-          </a:bodyPr>
-          <a:lstStyle/>
-          <a:p>
-            <a:pPr algn="ctr"/>
-            <a:r>
-              <a:rPr sz="1200" b="0">
+              <a:rPr sz="1300" b="0">
                 <a:solidFill>
                   <a:srgbClr val="ECF0F1"/>
                 </a:solidFill>
@@ -7291,7 +7097,7 @@
       </p:sp>
       <p:sp>
         <p:nvSpPr>
-          <p:cNvPr id="34" name="TextBox 33"/>
+          <p:cNvPr id="30" name="TextBox 29"/>
           <p:cNvSpPr txBox="1"/>
           <p:nvPr/>
         </p:nvSpPr>
@@ -7341,12 +7147,20 @@
         <p:nvPr/>
       </p:nvGrpSpPr>
       <p:grpSpPr/>
-      <p:sp>
-        <p:nvSpPr>
-          <p:cNvPr id="2" name="Rectangle 1"/>
-          <p:cNvSpPr/>
-          <p:nvPr/>
-        </p:nvSpPr>
+      <p:pic>
+        <p:nvPicPr>
+          <p:cNvPr id="2" name="Picture 1" descr="10_dashboard.jpg"/>
+          <p:cNvPicPr>
+            <a:picLocks noChangeAspect="1"/>
+          </p:cNvPicPr>
+          <p:nvPr/>
+        </p:nvPicPr>
+        <p:blipFill>
+          <a:blip r:embed="rId2"/>
+          <a:stretch>
+            <a:fillRect/>
+          </a:stretch>
+        </p:blipFill>
         <p:spPr>
           <a:xfrm>
             <a:off x="0" y="0"/>
@@ -7355,8 +7169,26 @@
           <a:prstGeom prst="rect">
             <a:avLst/>
           </a:prstGeom>
+        </p:spPr>
+      </p:pic>
+      <p:sp>
+        <p:nvSpPr>
+          <p:cNvPr id="3" name="Rectangle 2"/>
+          <p:cNvSpPr/>
+          <p:nvPr/>
+        </p:nvSpPr>
+        <p:spPr>
+          <a:xfrm>
+            <a:off x="0" y="0"/>
+            <a:ext cx="12191695" cy="6858000"/>
+          </a:xfrm>
+          <a:prstGeom prst="rect">
+            <a:avLst/>
+          </a:prstGeom>
           <a:solidFill>
-            <a:srgbClr val="1B2838"/>
+            <a:srgbClr val="1B2838">
+              <a:alpha val="75000"/>
+            </a:srgbClr>
           </a:solidFill>
           <a:ln>
             <a:noFill/>
@@ -7386,14 +7218,14 @@
       </p:sp>
       <p:sp>
         <p:nvSpPr>
-          <p:cNvPr id="3" name="TextBox 2"/>
+          <p:cNvPr id="4" name="TextBox 3"/>
           <p:cNvSpPr txBox="1"/>
           <p:nvPr/>
         </p:nvSpPr>
         <p:spPr>
           <a:xfrm>
-            <a:off x="457200" y="365760"/>
-            <a:ext cx="10972800" cy="914400"/>
+            <a:off x="457200" y="274320"/>
+            <a:ext cx="3657600" cy="365760"/>
           </a:xfrm>
           <a:prstGeom prst="rect">
             <a:avLst/>
@@ -7406,6 +7238,40 @@
           </a:bodyPr>
           <a:lstStyle/>
           <a:p>
+            <a:pPr algn="l"/>
+            <a:r>
+              <a:rPr sz="1100" b="1">
+                <a:solidFill>
+                  <a:srgbClr val="F39C12"/>
+                </a:solidFill>
+              </a:rPr>
+              <a:t>ARCHITECTURE</a:t>
+            </a:r>
+          </a:p>
+        </p:txBody>
+      </p:sp>
+      <p:sp>
+        <p:nvSpPr>
+          <p:cNvPr id="5" name="TextBox 4"/>
+          <p:cNvSpPr txBox="1"/>
+          <p:nvPr/>
+        </p:nvSpPr>
+        <p:spPr>
+          <a:xfrm>
+            <a:off x="457200" y="731520"/>
+            <a:ext cx="10972800" cy="914400"/>
+          </a:xfrm>
+          <a:prstGeom prst="rect">
+            <a:avLst/>
+          </a:prstGeom>
+          <a:noFill/>
+        </p:spPr>
+        <p:txBody>
+          <a:bodyPr wrap="square">
+            <a:spAutoFit/>
+          </a:bodyPr>
+          <a:lstStyle/>
+          <a:p>
             <a:pPr algn="ctr"/>
             <a:r>
               <a:rPr sz="3600" b="1">
@@ -7420,13 +7286,13 @@
       </p:sp>
       <p:sp>
         <p:nvSpPr>
-          <p:cNvPr id="4" name="Rounded Rectangle 3"/>
+          <p:cNvPr id="6" name="Rounded Rectangle 5"/>
           <p:cNvSpPr/>
           <p:nvPr/>
         </p:nvSpPr>
         <p:spPr>
           <a:xfrm>
-            <a:off x="1005840" y="1645920"/>
+            <a:off x="1005840" y="1828800"/>
             <a:ext cx="10058400" cy="1097280"/>
           </a:xfrm>
           <a:prstGeom prst="roundRect">
@@ -7463,13 +7329,13 @@
       </p:sp>
       <p:sp>
         <p:nvSpPr>
-          <p:cNvPr id="5" name="Rectangle 4"/>
+          <p:cNvPr id="7" name="Rectangle 6"/>
           <p:cNvSpPr/>
           <p:nvPr/>
         </p:nvSpPr>
         <p:spPr>
           <a:xfrm>
-            <a:off x="1005840" y="1645920"/>
+            <a:off x="1005840" y="1828800"/>
             <a:ext cx="73152" cy="1097280"/>
           </a:xfrm>
           <a:prstGeom prst="rect">
@@ -7506,14 +7372,14 @@
       </p:sp>
       <p:sp>
         <p:nvSpPr>
-          <p:cNvPr id="6" name="TextBox 5"/>
+          <p:cNvPr id="8" name="TextBox 7"/>
           <p:cNvSpPr txBox="1"/>
           <p:nvPr/>
         </p:nvSpPr>
         <p:spPr>
           <a:xfrm>
-            <a:off x="1371600" y="1783080"/>
-            <a:ext cx="731520" cy="822960"/>
+            <a:off x="1463040" y="1965960"/>
+            <a:ext cx="8686800" cy="548640"/>
           </a:xfrm>
           <a:prstGeom prst="rect">
             <a:avLst/>
@@ -7526,28 +7392,28 @@
           </a:bodyPr>
           <a:lstStyle/>
           <a:p>
-            <a:pPr algn="ctr"/>
-            <a:r>
-              <a:rPr sz="2800" b="0">
+            <a:pPr algn="l"/>
+            <a:r>
+              <a:rPr sz="2000" b="1">
                 <a:solidFill>
                   <a:srgbClr val="FFFFFF"/>
                 </a:solidFill>
               </a:rPr>
-              <a:t>📱</a:t>
-            </a:r>
-          </a:p>
-        </p:txBody>
-      </p:sp>
-      <p:sp>
-        <p:nvSpPr>
-          <p:cNvPr id="7" name="TextBox 6"/>
+              <a:t>Works on any device</a:t>
+            </a:r>
+          </a:p>
+        </p:txBody>
+      </p:sp>
+      <p:sp>
+        <p:nvSpPr>
+          <p:cNvPr id="9" name="TextBox 8"/>
           <p:cNvSpPr txBox="1"/>
           <p:nvPr/>
         </p:nvSpPr>
         <p:spPr>
           <a:xfrm>
-            <a:off x="2286000" y="1737360"/>
-            <a:ext cx="8229600" cy="548640"/>
+            <a:off x="1463040" y="2423160"/>
+            <a:ext cx="8686800" cy="457200"/>
           </a:xfrm>
           <a:prstGeom prst="rect">
             <a:avLst/>
@@ -7562,40 +7428,6 @@
           <a:p>
             <a:pPr algn="l"/>
             <a:r>
-              <a:rPr sz="2000" b="1">
-                <a:solidFill>
-                  <a:srgbClr val="FFFFFF"/>
-                </a:solidFill>
-              </a:rPr>
-              <a:t>Works on any device</a:t>
-            </a:r>
-          </a:p>
-        </p:txBody>
-      </p:sp>
-      <p:sp>
-        <p:nvSpPr>
-          <p:cNvPr id="8" name="TextBox 7"/>
-          <p:cNvSpPr txBox="1"/>
-          <p:nvPr/>
-        </p:nvSpPr>
-        <p:spPr>
-          <a:xfrm>
-            <a:off x="2286000" y="2240280"/>
-            <a:ext cx="8229600" cy="457200"/>
-          </a:xfrm>
-          <a:prstGeom prst="rect">
-            <a:avLst/>
-          </a:prstGeom>
-          <a:noFill/>
-        </p:spPr>
-        <p:txBody>
-          <a:bodyPr wrap="square">
-            <a:spAutoFit/>
-          </a:bodyPr>
-          <a:lstStyle/>
-          <a:p>
-            <a:pPr algn="l"/>
-            <a:r>
               <a:rPr sz="1400" b="0">
                 <a:solidFill>
                   <a:srgbClr val="ECF0F1"/>
@@ -7608,13 +7440,13 @@
       </p:sp>
       <p:sp>
         <p:nvSpPr>
-          <p:cNvPr id="9" name="Rounded Rectangle 8"/>
+          <p:cNvPr id="10" name="Rounded Rectangle 9"/>
           <p:cNvSpPr/>
           <p:nvPr/>
         </p:nvSpPr>
         <p:spPr>
           <a:xfrm>
-            <a:off x="1005840" y="3017520"/>
+            <a:off x="1005840" y="3200400"/>
             <a:ext cx="10058400" cy="1097280"/>
           </a:xfrm>
           <a:prstGeom prst="roundRect">
@@ -7651,13 +7483,13 @@
       </p:sp>
       <p:sp>
         <p:nvSpPr>
-          <p:cNvPr id="10" name="Rectangle 9"/>
+          <p:cNvPr id="11" name="Rectangle 10"/>
           <p:cNvSpPr/>
           <p:nvPr/>
         </p:nvSpPr>
         <p:spPr>
           <a:xfrm>
-            <a:off x="1005840" y="3017520"/>
+            <a:off x="1005840" y="3200400"/>
             <a:ext cx="73152" cy="1097280"/>
           </a:xfrm>
           <a:prstGeom prst="rect">
@@ -7694,14 +7526,14 @@
       </p:sp>
       <p:sp>
         <p:nvSpPr>
-          <p:cNvPr id="11" name="TextBox 10"/>
+          <p:cNvPr id="12" name="TextBox 11"/>
           <p:cNvSpPr txBox="1"/>
           <p:nvPr/>
         </p:nvSpPr>
         <p:spPr>
           <a:xfrm>
-            <a:off x="1371600" y="3154680"/>
-            <a:ext cx="731520" cy="822960"/>
+            <a:off x="1463040" y="3337560"/>
+            <a:ext cx="8686800" cy="548640"/>
           </a:xfrm>
           <a:prstGeom prst="rect">
             <a:avLst/>
@@ -7714,28 +7546,28 @@
           </a:bodyPr>
           <a:lstStyle/>
           <a:p>
-            <a:pPr algn="ctr"/>
-            <a:r>
-              <a:rPr sz="2800" b="0">
+            <a:pPr algn="l"/>
+            <a:r>
+              <a:rPr sz="2000" b="1">
                 <a:solidFill>
                   <a:srgbClr val="FFFFFF"/>
                 </a:solidFill>
               </a:rPr>
-              <a:t>⚡</a:t>
-            </a:r>
-          </a:p>
-        </p:txBody>
-      </p:sp>
-      <p:sp>
-        <p:nvSpPr>
-          <p:cNvPr id="12" name="TextBox 11"/>
+              <a:t>Lightning-fast &amp; beautiful</a:t>
+            </a:r>
+          </a:p>
+        </p:txBody>
+      </p:sp>
+      <p:sp>
+        <p:nvSpPr>
+          <p:cNvPr id="13" name="TextBox 12"/>
           <p:cNvSpPr txBox="1"/>
           <p:nvPr/>
         </p:nvSpPr>
         <p:spPr>
           <a:xfrm>
-            <a:off x="2286000" y="3108960"/>
-            <a:ext cx="8229600" cy="548640"/>
+            <a:off x="1463040" y="3794760"/>
+            <a:ext cx="8686800" cy="457200"/>
           </a:xfrm>
           <a:prstGeom prst="rect">
             <a:avLst/>
@@ -7750,40 +7582,6 @@
           <a:p>
             <a:pPr algn="l"/>
             <a:r>
-              <a:rPr sz="2000" b="1">
-                <a:solidFill>
-                  <a:srgbClr val="FFFFFF"/>
-                </a:solidFill>
-              </a:rPr>
-              <a:t>Lightning-fast &amp; beautiful</a:t>
-            </a:r>
-          </a:p>
-        </p:txBody>
-      </p:sp>
-      <p:sp>
-        <p:nvSpPr>
-          <p:cNvPr id="13" name="TextBox 12"/>
-          <p:cNvSpPr txBox="1"/>
-          <p:nvPr/>
-        </p:nvSpPr>
-        <p:spPr>
-          <a:xfrm>
-            <a:off x="2286000" y="3611880"/>
-            <a:ext cx="8229600" cy="457200"/>
-          </a:xfrm>
-          <a:prstGeom prst="rect">
-            <a:avLst/>
-          </a:prstGeom>
-          <a:noFill/>
-        </p:spPr>
-        <p:txBody>
-          <a:bodyPr wrap="square">
-            <a:spAutoFit/>
-          </a:bodyPr>
-          <a:lstStyle/>
-          <a:p>
-            <a:pPr algn="l"/>
-            <a:r>
               <a:rPr sz="1400" b="0">
                 <a:solidFill>
                   <a:srgbClr val="ECF0F1"/>
@@ -7802,7 +7600,7 @@
         </p:nvSpPr>
         <p:spPr>
           <a:xfrm>
-            <a:off x="1005840" y="4389120"/>
+            <a:off x="1005840" y="4572000"/>
             <a:ext cx="10058400" cy="1097280"/>
           </a:xfrm>
           <a:prstGeom prst="roundRect">
@@ -7845,7 +7643,7 @@
         </p:nvSpPr>
         <p:spPr>
           <a:xfrm>
-            <a:off x="1005840" y="4389120"/>
+            <a:off x="1005840" y="4572000"/>
             <a:ext cx="73152" cy="1097280"/>
           </a:xfrm>
           <a:prstGeom prst="rect">
@@ -7888,8 +7686,8 @@
         </p:nvSpPr>
         <p:spPr>
           <a:xfrm>
-            <a:off x="1371600" y="4526280"/>
-            <a:ext cx="731520" cy="822960"/>
+            <a:off x="1463040" y="4709160"/>
+            <a:ext cx="8686800" cy="548640"/>
           </a:xfrm>
           <a:prstGeom prst="rect">
             <a:avLst/>
@@ -7902,14 +7700,14 @@
           </a:bodyPr>
           <a:lstStyle/>
           <a:p>
-            <a:pPr algn="ctr"/>
-            <a:r>
-              <a:rPr sz="2800" b="0">
+            <a:pPr algn="l"/>
+            <a:r>
+              <a:rPr sz="2000" b="1">
                 <a:solidFill>
                   <a:srgbClr val="FFFFFF"/>
                 </a:solidFill>
               </a:rPr>
-              <a:t>🔒</a:t>
+              <a:t>Your data is always safe</a:t>
             </a:r>
           </a:p>
         </p:txBody>
@@ -7922,8 +7720,8 @@
         </p:nvSpPr>
         <p:spPr>
           <a:xfrm>
-            <a:off x="2286000" y="4480560"/>
-            <a:ext cx="8229600" cy="548640"/>
+            <a:off x="1463040" y="5166360"/>
+            <a:ext cx="8686800" cy="457200"/>
           </a:xfrm>
           <a:prstGeom prst="rect">
             <a:avLst/>
@@ -7938,40 +7736,6 @@
           <a:p>
             <a:pPr algn="l"/>
             <a:r>
-              <a:rPr sz="2000" b="1">
-                <a:solidFill>
-                  <a:srgbClr val="FFFFFF"/>
-                </a:solidFill>
-              </a:rPr>
-              <a:t>Your data is always safe</a:t>
-            </a:r>
-          </a:p>
-        </p:txBody>
-      </p:sp>
-      <p:sp>
-        <p:nvSpPr>
-          <p:cNvPr id="18" name="TextBox 17"/>
-          <p:cNvSpPr txBox="1"/>
-          <p:nvPr/>
-        </p:nvSpPr>
-        <p:spPr>
-          <a:xfrm>
-            <a:off x="2286000" y="4983480"/>
-            <a:ext cx="8229600" cy="457200"/>
-          </a:xfrm>
-          <a:prstGeom prst="rect">
-            <a:avLst/>
-          </a:prstGeom>
-          <a:noFill/>
-        </p:spPr>
-        <p:txBody>
-          <a:bodyPr wrap="square">
-            <a:spAutoFit/>
-          </a:bodyPr>
-          <a:lstStyle/>
-          <a:p>
-            <a:pPr algn="l"/>
-            <a:r>
               <a:rPr sz="1400" b="0">
                 <a:solidFill>
                   <a:srgbClr val="ECF0F1"/>
@@ -7984,13 +7748,13 @@
       </p:sp>
       <p:sp>
         <p:nvSpPr>
-          <p:cNvPr id="19" name="Rounded Rectangle 18"/>
+          <p:cNvPr id="18" name="Rounded Rectangle 17"/>
           <p:cNvSpPr/>
           <p:nvPr/>
         </p:nvSpPr>
         <p:spPr>
           <a:xfrm>
-            <a:off x="1005840" y="5760720"/>
+            <a:off x="1005840" y="5943600"/>
             <a:ext cx="10058400" cy="1097280"/>
           </a:xfrm>
           <a:prstGeom prst="roundRect">
@@ -8027,13 +7791,13 @@
       </p:sp>
       <p:sp>
         <p:nvSpPr>
-          <p:cNvPr id="20" name="Rectangle 19"/>
+          <p:cNvPr id="19" name="Rectangle 18"/>
           <p:cNvSpPr/>
           <p:nvPr/>
         </p:nvSpPr>
         <p:spPr>
           <a:xfrm>
-            <a:off x="1005840" y="5760720"/>
+            <a:off x="1005840" y="5943600"/>
             <a:ext cx="73152" cy="1097280"/>
           </a:xfrm>
           <a:prstGeom prst="rect">
@@ -8070,14 +7834,14 @@
       </p:sp>
       <p:sp>
         <p:nvSpPr>
-          <p:cNvPr id="21" name="TextBox 20"/>
+          <p:cNvPr id="20" name="TextBox 19"/>
           <p:cNvSpPr txBox="1"/>
           <p:nvPr/>
         </p:nvSpPr>
         <p:spPr>
           <a:xfrm>
-            <a:off x="1371600" y="5897880"/>
-            <a:ext cx="731520" cy="822960"/>
+            <a:off x="1463040" y="6080760"/>
+            <a:ext cx="8686800" cy="548640"/>
           </a:xfrm>
           <a:prstGeom prst="rect">
             <a:avLst/>
@@ -8090,28 +7854,28 @@
           </a:bodyPr>
           <a:lstStyle/>
           <a:p>
-            <a:pPr algn="ctr"/>
-            <a:r>
-              <a:rPr sz="2800" b="0">
+            <a:pPr algn="l"/>
+            <a:r>
+              <a:rPr sz="2000" b="1">
                 <a:solidFill>
                   <a:srgbClr val="FFFFFF"/>
                 </a:solidFill>
               </a:rPr>
-              <a:t>🧠</a:t>
-            </a:r>
-          </a:p>
-        </p:txBody>
-      </p:sp>
-      <p:sp>
-        <p:nvSpPr>
-          <p:cNvPr id="22" name="TextBox 21"/>
+              <a:t>Smart AI that learns your habits</a:t>
+            </a:r>
+          </a:p>
+        </p:txBody>
+      </p:sp>
+      <p:sp>
+        <p:nvSpPr>
+          <p:cNvPr id="21" name="TextBox 20"/>
           <p:cNvSpPr txBox="1"/>
           <p:nvPr/>
         </p:nvSpPr>
         <p:spPr>
           <a:xfrm>
-            <a:off x="2286000" y="5852160"/>
-            <a:ext cx="8229600" cy="548640"/>
+            <a:off x="1463040" y="6537960"/>
+            <a:ext cx="8686800" cy="457200"/>
           </a:xfrm>
           <a:prstGeom prst="rect">
             <a:avLst/>
@@ -8126,40 +7890,6 @@
           <a:p>
             <a:pPr algn="l"/>
             <a:r>
-              <a:rPr sz="2000" b="1">
-                <a:solidFill>
-                  <a:srgbClr val="FFFFFF"/>
-                </a:solidFill>
-              </a:rPr>
-              <a:t>Smart AI that learns your habits</a:t>
-            </a:r>
-          </a:p>
-        </p:txBody>
-      </p:sp>
-      <p:sp>
-        <p:nvSpPr>
-          <p:cNvPr id="23" name="TextBox 22"/>
-          <p:cNvSpPr txBox="1"/>
-          <p:nvPr/>
-        </p:nvSpPr>
-        <p:spPr>
-          <a:xfrm>
-            <a:off x="2286000" y="6355080"/>
-            <a:ext cx="8229600" cy="457200"/>
-          </a:xfrm>
-          <a:prstGeom prst="rect">
-            <a:avLst/>
-          </a:prstGeom>
-          <a:noFill/>
-        </p:spPr>
-        <p:txBody>
-          <a:bodyPr wrap="square">
-            <a:spAutoFit/>
-          </a:bodyPr>
-          <a:lstStyle/>
-          <a:p>
-            <a:pPr algn="l"/>
-            <a:r>
               <a:rPr sz="1400" b="0">
                 <a:solidFill>
                   <a:srgbClr val="ECF0F1"/>
@@ -8172,7 +7902,7 @@
       </p:sp>
       <p:sp>
         <p:nvSpPr>
-          <p:cNvPr id="24" name="TextBox 23"/>
+          <p:cNvPr id="22" name="TextBox 21"/>
           <p:cNvSpPr txBox="1"/>
           <p:nvPr/>
         </p:nvSpPr>
@@ -8222,12 +7952,20 @@
         <p:nvPr/>
       </p:nvGrpSpPr>
       <p:grpSpPr/>
-      <p:sp>
-        <p:nvSpPr>
-          <p:cNvPr id="2" name="Rectangle 1"/>
-          <p:cNvSpPr/>
-          <p:nvPr/>
-        </p:nvSpPr>
+      <p:pic>
+        <p:nvPicPr>
+          <p:cNvPr id="2" name="Picture 1" descr="07_community.jpg"/>
+          <p:cNvPicPr>
+            <a:picLocks noChangeAspect="1"/>
+          </p:cNvPicPr>
+          <p:nvPr/>
+        </p:nvPicPr>
+        <p:blipFill>
+          <a:blip r:embed="rId2"/>
+          <a:stretch>
+            <a:fillRect/>
+          </a:stretch>
+        </p:blipFill>
         <p:spPr>
           <a:xfrm>
             <a:off x="0" y="0"/>
@@ -8236,8 +7974,26 @@
           <a:prstGeom prst="rect">
             <a:avLst/>
           </a:prstGeom>
+        </p:spPr>
+      </p:pic>
+      <p:sp>
+        <p:nvSpPr>
+          <p:cNvPr id="3" name="Rectangle 2"/>
+          <p:cNvSpPr/>
+          <p:nvPr/>
+        </p:nvSpPr>
+        <p:spPr>
+          <a:xfrm>
+            <a:off x="0" y="0"/>
+            <a:ext cx="12191695" cy="6858000"/>
+          </a:xfrm>
+          <a:prstGeom prst="rect">
+            <a:avLst/>
+          </a:prstGeom>
           <a:solidFill>
-            <a:srgbClr val="1B2838"/>
+            <a:srgbClr val="1B2838">
+              <a:alpha val="75000"/>
+            </a:srgbClr>
           </a:solidFill>
           <a:ln>
             <a:noFill/>
@@ -8267,14 +8023,14 @@
       </p:sp>
       <p:sp>
         <p:nvSpPr>
-          <p:cNvPr id="3" name="TextBox 2"/>
+          <p:cNvPr id="4" name="TextBox 3"/>
           <p:cNvSpPr txBox="1"/>
           <p:nvPr/>
         </p:nvSpPr>
         <p:spPr>
           <a:xfrm>
-            <a:off x="457200" y="457200"/>
-            <a:ext cx="10972800" cy="914400"/>
+            <a:off x="457200" y="274320"/>
+            <a:ext cx="3657600" cy="365760"/>
           </a:xfrm>
           <a:prstGeom prst="rect">
             <a:avLst/>
@@ -8287,6 +8043,40 @@
           </a:bodyPr>
           <a:lstStyle/>
           <a:p>
+            <a:pPr algn="l"/>
+            <a:r>
+              <a:rPr sz="1100" b="1">
+                <a:solidFill>
+                  <a:srgbClr val="F39C12"/>
+                </a:solidFill>
+              </a:rPr>
+              <a:t>PROJECTED IMPACT</a:t>
+            </a:r>
+          </a:p>
+        </p:txBody>
+      </p:sp>
+      <p:sp>
+        <p:nvSpPr>
+          <p:cNvPr id="5" name="TextBox 4"/>
+          <p:cNvSpPr txBox="1"/>
+          <p:nvPr/>
+        </p:nvSpPr>
+        <p:spPr>
+          <a:xfrm>
+            <a:off x="457200" y="731520"/>
+            <a:ext cx="10972800" cy="914400"/>
+          </a:xfrm>
+          <a:prstGeom prst="rect">
+            <a:avLst/>
+          </a:prstGeom>
+          <a:noFill/>
+        </p:spPr>
+        <p:txBody>
+          <a:bodyPr wrap="square">
+            <a:spAutoFit/>
+          </a:bodyPr>
+          <a:lstStyle/>
+          <a:p>
             <a:pPr algn="ctr"/>
             <a:r>
               <a:rPr sz="3600" b="1">
@@ -8301,7 +8091,7 @@
       </p:sp>
       <p:sp>
         <p:nvSpPr>
-          <p:cNvPr id="4" name="Rounded Rectangle 3"/>
+          <p:cNvPr id="6" name="Rounded Rectangle 5"/>
           <p:cNvSpPr/>
           <p:nvPr/>
         </p:nvSpPr>
@@ -8344,7 +8134,7 @@
       </p:sp>
       <p:sp>
         <p:nvSpPr>
-          <p:cNvPr id="5" name="Rectangle 4"/>
+          <p:cNvPr id="7" name="Rectangle 6"/>
           <p:cNvSpPr/>
           <p:nvPr/>
         </p:nvSpPr>
@@ -8387,7 +8177,7 @@
       </p:sp>
       <p:sp>
         <p:nvSpPr>
-          <p:cNvPr id="6" name="TextBox 5"/>
+          <p:cNvPr id="8" name="TextBox 7"/>
           <p:cNvSpPr txBox="1"/>
           <p:nvPr/>
         </p:nvSpPr>
@@ -8421,7 +8211,7 @@
       </p:sp>
       <p:sp>
         <p:nvSpPr>
-          <p:cNvPr id="7" name="TextBox 6"/>
+          <p:cNvPr id="9" name="TextBox 8"/>
           <p:cNvSpPr txBox="1"/>
           <p:nvPr/>
         </p:nvSpPr>
@@ -8455,7 +8245,7 @@
       </p:sp>
       <p:sp>
         <p:nvSpPr>
-          <p:cNvPr id="8" name="Rounded Rectangle 7"/>
+          <p:cNvPr id="10" name="Rounded Rectangle 9"/>
           <p:cNvSpPr/>
           <p:nvPr/>
         </p:nvSpPr>
@@ -8498,7 +8288,7 @@
       </p:sp>
       <p:sp>
         <p:nvSpPr>
-          <p:cNvPr id="9" name="Rectangle 8"/>
+          <p:cNvPr id="11" name="Rectangle 10"/>
           <p:cNvSpPr/>
           <p:nvPr/>
         </p:nvSpPr>
@@ -8541,7 +8331,7 @@
       </p:sp>
       <p:sp>
         <p:nvSpPr>
-          <p:cNvPr id="10" name="TextBox 9"/>
+          <p:cNvPr id="12" name="TextBox 11"/>
           <p:cNvSpPr txBox="1"/>
           <p:nvPr/>
         </p:nvSpPr>
@@ -8575,7 +8365,7 @@
       </p:sp>
       <p:sp>
         <p:nvSpPr>
-          <p:cNvPr id="11" name="TextBox 10"/>
+          <p:cNvPr id="13" name="TextBox 12"/>
           <p:cNvSpPr txBox="1"/>
           <p:nvPr/>
         </p:nvSpPr>
@@ -8609,7 +8399,7 @@
       </p:sp>
       <p:sp>
         <p:nvSpPr>
-          <p:cNvPr id="12" name="Rounded Rectangle 11"/>
+          <p:cNvPr id="14" name="Rounded Rectangle 13"/>
           <p:cNvSpPr/>
           <p:nvPr/>
         </p:nvSpPr>
@@ -8652,7 +8442,7 @@
       </p:sp>
       <p:sp>
         <p:nvSpPr>
-          <p:cNvPr id="13" name="Rectangle 12"/>
+          <p:cNvPr id="15" name="Rectangle 14"/>
           <p:cNvSpPr/>
           <p:nvPr/>
         </p:nvSpPr>
@@ -8695,7 +8485,7 @@
       </p:sp>
       <p:sp>
         <p:nvSpPr>
-          <p:cNvPr id="14" name="TextBox 13"/>
+          <p:cNvPr id="16" name="TextBox 15"/>
           <p:cNvSpPr txBox="1"/>
           <p:nvPr/>
         </p:nvSpPr>
@@ -8722,14 +8512,14 @@
                   <a:srgbClr val="2ECC71"/>
                 </a:solidFill>
               </a:rPr>
-              <a:t>ZERO</a:t>
-            </a:r>
-          </a:p>
-        </p:txBody>
-      </p:sp>
-      <p:sp>
-        <p:nvSpPr>
-          <p:cNvPr id="15" name="TextBox 14"/>
+              <a:t>Zero</a:t>
+            </a:r>
+          </a:p>
+        </p:txBody>
+      </p:sp>
+      <p:sp>
+        <p:nvSpPr>
+          <p:cNvPr id="17" name="TextBox 16"/>
           <p:cNvSpPr txBox="1"/>
           <p:nvPr/>
         </p:nvSpPr>
@@ -8763,7 +8553,7 @@
       </p:sp>
       <p:sp>
         <p:nvSpPr>
-          <p:cNvPr id="16" name="TextBox 15"/>
+          <p:cNvPr id="18" name="TextBox 17"/>
           <p:cNvSpPr txBox="1"/>
           <p:nvPr/>
         </p:nvSpPr>
@@ -8813,12 +8603,20 @@
         <p:nvPr/>
       </p:nvGrpSpPr>
       <p:grpSpPr/>
-      <p:sp>
-        <p:nvSpPr>
-          <p:cNvPr id="2" name="Rectangle 1"/>
-          <p:cNvSpPr/>
-          <p:nvPr/>
-        </p:nvSpPr>
+      <p:pic>
+        <p:nvPicPr>
+          <p:cNvPr id="2" name="Picture 1" descr="08_growth.jpg"/>
+          <p:cNvPicPr>
+            <a:picLocks noChangeAspect="1"/>
+          </p:cNvPicPr>
+          <p:nvPr/>
+        </p:nvPicPr>
+        <p:blipFill>
+          <a:blip r:embed="rId2"/>
+          <a:stretch>
+            <a:fillRect/>
+          </a:stretch>
+        </p:blipFill>
         <p:spPr>
           <a:xfrm>
             <a:off x="0" y="0"/>
@@ -8827,8 +8625,26 @@
           <a:prstGeom prst="rect">
             <a:avLst/>
           </a:prstGeom>
+        </p:spPr>
+      </p:pic>
+      <p:sp>
+        <p:nvSpPr>
+          <p:cNvPr id="3" name="Rectangle 2"/>
+          <p:cNvSpPr/>
+          <p:nvPr/>
+        </p:nvSpPr>
+        <p:spPr>
+          <a:xfrm>
+            <a:off x="0" y="0"/>
+            <a:ext cx="12191695" cy="6858000"/>
+          </a:xfrm>
+          <a:prstGeom prst="rect">
+            <a:avLst/>
+          </a:prstGeom>
           <a:solidFill>
-            <a:srgbClr val="1B2838"/>
+            <a:srgbClr val="1B2838">
+              <a:alpha val="75000"/>
+            </a:srgbClr>
           </a:solidFill>
           <a:ln>
             <a:noFill/>
@@ -8858,14 +8674,14 @@
       </p:sp>
       <p:sp>
         <p:nvSpPr>
-          <p:cNvPr id="3" name="TextBox 2"/>
+          <p:cNvPr id="4" name="TextBox 3"/>
           <p:cNvSpPr txBox="1"/>
           <p:nvPr/>
         </p:nvSpPr>
         <p:spPr>
           <a:xfrm>
-            <a:off x="457200" y="365760"/>
-            <a:ext cx="10972800" cy="914400"/>
+            <a:off x="457200" y="274320"/>
+            <a:ext cx="3657600" cy="365760"/>
           </a:xfrm>
           <a:prstGeom prst="rect">
             <a:avLst/>
@@ -8878,6 +8694,40 @@
           </a:bodyPr>
           <a:lstStyle/>
           <a:p>
+            <a:pPr algn="l"/>
+            <a:r>
+              <a:rPr sz="1100" b="1">
+                <a:solidFill>
+                  <a:srgbClr val="F39C12"/>
+                </a:solidFill>
+              </a:rPr>
+              <a:t>THE FUTURE</a:t>
+            </a:r>
+          </a:p>
+        </p:txBody>
+      </p:sp>
+      <p:sp>
+        <p:nvSpPr>
+          <p:cNvPr id="5" name="TextBox 4"/>
+          <p:cNvSpPr txBox="1"/>
+          <p:nvPr/>
+        </p:nvSpPr>
+        <p:spPr>
+          <a:xfrm>
+            <a:off x="457200" y="731520"/>
+            <a:ext cx="10972800" cy="914400"/>
+          </a:xfrm>
+          <a:prstGeom prst="rect">
+            <a:avLst/>
+          </a:prstGeom>
+          <a:noFill/>
+        </p:spPr>
+        <p:txBody>
+          <a:bodyPr wrap="square">
+            <a:spAutoFit/>
+          </a:bodyPr>
+          <a:lstStyle/>
+          <a:p>
             <a:pPr algn="ctr"/>
             <a:r>
               <a:rPr sz="3600" b="1">
@@ -8892,7 +8742,7 @@
       </p:sp>
       <p:sp>
         <p:nvSpPr>
-          <p:cNvPr id="4" name="Rectangle 3"/>
+          <p:cNvPr id="6" name="Rectangle 5"/>
           <p:cNvSpPr/>
           <p:nvPr/>
         </p:nvSpPr>
@@ -8935,7 +8785,7 @@
       </p:sp>
       <p:sp>
         <p:nvSpPr>
-          <p:cNvPr id="5" name="Oval 4"/>
+          <p:cNvPr id="7" name="Oval 6"/>
           <p:cNvSpPr/>
           <p:nvPr/>
         </p:nvSpPr>
@@ -8986,7 +8836,7 @@
       </p:sp>
       <p:sp>
         <p:nvSpPr>
-          <p:cNvPr id="6" name="Rounded Rectangle 5"/>
+          <p:cNvPr id="8" name="Rounded Rectangle 7"/>
           <p:cNvSpPr/>
           <p:nvPr/>
         </p:nvSpPr>
@@ -9029,7 +8879,7 @@
       </p:sp>
       <p:sp>
         <p:nvSpPr>
-          <p:cNvPr id="7" name="Rectangle 6"/>
+          <p:cNvPr id="9" name="Rectangle 8"/>
           <p:cNvSpPr/>
           <p:nvPr/>
         </p:nvSpPr>
@@ -9072,7 +8922,7 @@
       </p:sp>
       <p:sp>
         <p:nvSpPr>
-          <p:cNvPr id="8" name="TextBox 7"/>
+          <p:cNvPr id="10" name="TextBox 9"/>
           <p:cNvSpPr txBox="1"/>
           <p:nvPr/>
         </p:nvSpPr>
@@ -9099,14 +8949,15 @@
                   <a:srgbClr val="FFFFFF"/>
                 </a:solidFill>
               </a:rPr>
-              <a:t>📋 Smart Inventory &amp; Alerts</a:t>
-            </a:r>
-          </a:p>
-        </p:txBody>
-      </p:sp>
-      <p:sp>
-        <p:nvSpPr>
-          <p:cNvPr id="9" name="Oval 8"/>
+              <a:t>Smart Inventory
+&amp; Alerts</a:t>
+            </a:r>
+          </a:p>
+        </p:txBody>
+      </p:sp>
+      <p:sp>
+        <p:nvSpPr>
+          <p:cNvPr id="11" name="Oval 10"/>
           <p:cNvSpPr/>
           <p:nvPr/>
         </p:nvSpPr>
@@ -9157,7 +9008,7 @@
       </p:sp>
       <p:sp>
         <p:nvSpPr>
-          <p:cNvPr id="10" name="Rounded Rectangle 9"/>
+          <p:cNvPr id="12" name="Rounded Rectangle 11"/>
           <p:cNvSpPr/>
           <p:nvPr/>
         </p:nvSpPr>
@@ -9200,7 +9051,7 @@
       </p:sp>
       <p:sp>
         <p:nvSpPr>
-          <p:cNvPr id="11" name="Rectangle 10"/>
+          <p:cNvPr id="13" name="Rectangle 12"/>
           <p:cNvSpPr/>
           <p:nvPr/>
         </p:nvSpPr>
@@ -9243,7 +9094,7 @@
       </p:sp>
       <p:sp>
         <p:nvSpPr>
-          <p:cNvPr id="12" name="TextBox 11"/>
+          <p:cNvPr id="14" name="TextBox 13"/>
           <p:cNvSpPr txBox="1"/>
           <p:nvPr/>
         </p:nvSpPr>
@@ -9270,14 +9121,15 @@
                   <a:srgbClr val="FFFFFF"/>
                 </a:solidFill>
               </a:rPr>
-              <a:t>🧑‍🍳 AI Recipes &amp; Community Sharing</a:t>
-            </a:r>
-          </a:p>
-        </p:txBody>
-      </p:sp>
-      <p:sp>
-        <p:nvSpPr>
-          <p:cNvPr id="13" name="Oval 12"/>
+              <a:t>AI Recipes &amp;
+Community Sharing</a:t>
+            </a:r>
+          </a:p>
+        </p:txBody>
+      </p:sp>
+      <p:sp>
+        <p:nvSpPr>
+          <p:cNvPr id="15" name="Oval 14"/>
           <p:cNvSpPr/>
           <p:nvPr/>
         </p:nvSpPr>
@@ -9328,7 +9180,7 @@
       </p:sp>
       <p:sp>
         <p:nvSpPr>
-          <p:cNvPr id="14" name="Rounded Rectangle 13"/>
+          <p:cNvPr id="16" name="Rounded Rectangle 15"/>
           <p:cNvSpPr/>
           <p:nvPr/>
         </p:nvSpPr>
@@ -9371,7 +9223,7 @@
       </p:sp>
       <p:sp>
         <p:nvSpPr>
-          <p:cNvPr id="15" name="Rectangle 14"/>
+          <p:cNvPr id="17" name="Rectangle 16"/>
           <p:cNvSpPr/>
           <p:nvPr/>
         </p:nvSpPr>
@@ -9414,7 +9266,7 @@
       </p:sp>
       <p:sp>
         <p:nvSpPr>
-          <p:cNvPr id="16" name="TextBox 15"/>
+          <p:cNvPr id="18" name="TextBox 17"/>
           <p:cNvSpPr txBox="1"/>
           <p:nvPr/>
         </p:nvSpPr>
@@ -9441,14 +9293,15 @@
                   <a:srgbClr val="FFFFFF"/>
                 </a:solidFill>
               </a:rPr>
-              <a:t>🏪 Marketplace &amp; Donation Network</a:t>
-            </a:r>
-          </a:p>
-        </p:txBody>
-      </p:sp>
-      <p:sp>
-        <p:nvSpPr>
-          <p:cNvPr id="17" name="Oval 16"/>
+              <a:t>Marketplace &amp;
+Donation Network</a:t>
+            </a:r>
+          </a:p>
+        </p:txBody>
+      </p:sp>
+      <p:sp>
+        <p:nvSpPr>
+          <p:cNvPr id="19" name="Oval 18"/>
           <p:cNvSpPr/>
           <p:nvPr/>
         </p:nvSpPr>
@@ -9499,7 +9352,7 @@
       </p:sp>
       <p:sp>
         <p:nvSpPr>
-          <p:cNvPr id="18" name="Rounded Rectangle 17"/>
+          <p:cNvPr id="20" name="Rounded Rectangle 19"/>
           <p:cNvSpPr/>
           <p:nvPr/>
         </p:nvSpPr>
@@ -9542,7 +9395,7 @@
       </p:sp>
       <p:sp>
         <p:nvSpPr>
-          <p:cNvPr id="19" name="Rectangle 18"/>
+          <p:cNvPr id="21" name="Rectangle 20"/>
           <p:cNvSpPr/>
           <p:nvPr/>
         </p:nvSpPr>
@@ -9585,7 +9438,7 @@
       </p:sp>
       <p:sp>
         <p:nvSpPr>
-          <p:cNvPr id="20" name="TextBox 19"/>
+          <p:cNvPr id="22" name="TextBox 21"/>
           <p:cNvSpPr txBox="1"/>
           <p:nvPr/>
         </p:nvSpPr>
@@ -9612,14 +9465,15 @@
                   <a:srgbClr val="FFFFFF"/>
                 </a:solidFill>
               </a:rPr>
-              <a:t>🌍 Global Expansion &amp; Partnerships</a:t>
-            </a:r>
-          </a:p>
-        </p:txBody>
-      </p:sp>
-      <p:sp>
-        <p:nvSpPr>
-          <p:cNvPr id="21" name="TextBox 20"/>
+              <a:t>Global Expansion
+&amp; Partnerships</a:t>
+            </a:r>
+          </a:p>
+        </p:txBody>
+      </p:sp>
+      <p:sp>
+        <p:nvSpPr>
+          <p:cNvPr id="23" name="TextBox 22"/>
           <p:cNvSpPr txBox="1"/>
           <p:nvPr/>
         </p:nvSpPr>

</xml_diff>